<commit_message>
Cambio en la pptx
</commit_message>
<xml_diff>
--- a/docs/Optimizacion_Carga_Aeroportuaria.pptx
+++ b/docs/Optimizacion_Carga_Aeroportuaria.pptx
@@ -4,6 +4,9 @@
   <p:sldMasterIdLst>
     <p:sldMasterId id="2147483648" r:id="rId1"/>
   </p:sldMasterIdLst>
+  <p:notesMasterIdLst>
+    <p:notesMasterId r:id="rId16"/>
+  </p:notesMasterIdLst>
   <p:sldIdLst>
     <p:sldId id="256" r:id="rId2"/>
     <p:sldId id="257" r:id="rId3"/>
@@ -18,6 +21,7 @@
     <p:sldId id="266" r:id="rId12"/>
     <p:sldId id="267" r:id="rId13"/>
     <p:sldId id="268" r:id="rId14"/>
+    <p:sldId id="269" r:id="rId15"/>
   </p:sldIdLst>
   <p:sldSz cx="12192000" cy="6858000"/>
   <p:notesSz cx="6858000" cy="9144000"/>
@@ -133,6 +137,439 @@
     </p:ext>
   </p:extLst>
 </p:presentation>
+</file>
+
+<file path=ppt/notesMasters/notesMaster1.xml><?xml version="1.0" encoding="utf-8"?>
+<p:notesMaster xmlns:a="http://schemas.openxmlformats.org/drawingml/2006/main" xmlns:r="http://schemas.openxmlformats.org/officeDocument/2006/relationships" xmlns:p="http://schemas.openxmlformats.org/presentationml/2006/main">
+  <p:cSld>
+    <p:bg>
+      <p:bgRef idx="1001">
+        <a:schemeClr val="bg1"/>
+      </p:bgRef>
+    </p:bg>
+    <p:spTree>
+      <p:nvGrpSpPr>
+        <p:cNvPr id="1" name=""/>
+        <p:cNvGrpSpPr/>
+        <p:nvPr/>
+      </p:nvGrpSpPr>
+      <p:grpSpPr>
+        <a:xfrm>
+          <a:off x="0" y="0"/>
+          <a:ext cx="0" cy="0"/>
+          <a:chOff x="0" y="0"/>
+          <a:chExt cx="0" cy="0"/>
+        </a:xfrm>
+      </p:grpSpPr>
+      <p:sp>
+        <p:nvSpPr>
+          <p:cNvPr id="2" name="Header Placeholder 1"/>
+          <p:cNvSpPr>
+            <a:spLocks noGrp="1"/>
+          </p:cNvSpPr>
+          <p:nvPr>
+            <p:ph type="hdr" sz="quarter"/>
+          </p:nvPr>
+        </p:nvSpPr>
+        <p:spPr>
+          <a:xfrm>
+            <a:off x="0" y="0"/>
+            <a:ext cx="2971800" cy="458788"/>
+          </a:xfrm>
+          <a:prstGeom prst="rect">
+            <a:avLst/>
+          </a:prstGeom>
+        </p:spPr>
+        <p:txBody>
+          <a:bodyPr vert="horz" lIns="91440" tIns="45720" rIns="91440" bIns="45720" rtlCol="0"/>
+          <a:lstStyle>
+            <a:lvl1pPr algn="l">
+              <a:defRPr sz="1200"/>
+            </a:lvl1pPr>
+          </a:lstStyle>
+          <a:p>
+            <a:endParaRPr lang="en-GB"/>
+          </a:p>
+        </p:txBody>
+      </p:sp>
+      <p:sp>
+        <p:nvSpPr>
+          <p:cNvPr id="3" name="Date Placeholder 2"/>
+          <p:cNvSpPr>
+            <a:spLocks noGrp="1"/>
+          </p:cNvSpPr>
+          <p:nvPr>
+            <p:ph type="dt" idx="1"/>
+          </p:nvPr>
+        </p:nvSpPr>
+        <p:spPr>
+          <a:xfrm>
+            <a:off x="3884613" y="0"/>
+            <a:ext cx="2971800" cy="458788"/>
+          </a:xfrm>
+          <a:prstGeom prst="rect">
+            <a:avLst/>
+          </a:prstGeom>
+        </p:spPr>
+        <p:txBody>
+          <a:bodyPr vert="horz" lIns="91440" tIns="45720" rIns="91440" bIns="45720" rtlCol="0"/>
+          <a:lstStyle>
+            <a:lvl1pPr algn="r">
+              <a:defRPr sz="1200"/>
+            </a:lvl1pPr>
+          </a:lstStyle>
+          <a:p>
+            <a:fld id="{E71F7A84-5326-4125-B6DF-E255CA77FC4F}" type="datetimeFigureOut">
+              <a:rPr lang="en-GB" smtClean="0"/>
+              <a:t>11/06/2026</a:t>
+            </a:fld>
+            <a:endParaRPr lang="en-GB"/>
+          </a:p>
+        </p:txBody>
+      </p:sp>
+      <p:sp>
+        <p:nvSpPr>
+          <p:cNvPr id="4" name="Slide Image Placeholder 3"/>
+          <p:cNvSpPr>
+            <a:spLocks noGrp="1" noRot="1" noChangeAspect="1"/>
+          </p:cNvSpPr>
+          <p:nvPr>
+            <p:ph type="sldImg" idx="2"/>
+          </p:nvPr>
+        </p:nvSpPr>
+        <p:spPr>
+          <a:xfrm>
+            <a:off x="685800" y="1143000"/>
+            <a:ext cx="5486400" cy="3086100"/>
+          </a:xfrm>
+          <a:prstGeom prst="rect">
+            <a:avLst/>
+          </a:prstGeom>
+          <a:noFill/>
+          <a:ln w="12700">
+            <a:solidFill>
+              <a:prstClr val="black"/>
+            </a:solidFill>
+          </a:ln>
+        </p:spPr>
+        <p:txBody>
+          <a:bodyPr vert="horz" lIns="91440" tIns="45720" rIns="91440" bIns="45720" rtlCol="0" anchor="ctr"/>
+          <a:lstStyle/>
+          <a:p>
+            <a:endParaRPr lang="en-GB"/>
+          </a:p>
+        </p:txBody>
+      </p:sp>
+      <p:sp>
+        <p:nvSpPr>
+          <p:cNvPr id="5" name="Notes Placeholder 4"/>
+          <p:cNvSpPr>
+            <a:spLocks noGrp="1"/>
+          </p:cNvSpPr>
+          <p:nvPr>
+            <p:ph type="body" sz="quarter" idx="3"/>
+          </p:nvPr>
+        </p:nvSpPr>
+        <p:spPr>
+          <a:xfrm>
+            <a:off x="685800" y="4400550"/>
+            <a:ext cx="5486400" cy="3600450"/>
+          </a:xfrm>
+          <a:prstGeom prst="rect">
+            <a:avLst/>
+          </a:prstGeom>
+        </p:spPr>
+        <p:txBody>
+          <a:bodyPr vert="horz" lIns="91440" tIns="45720" rIns="91440" bIns="45720" rtlCol="0"/>
+          <a:lstStyle/>
+          <a:p>
+            <a:pPr lvl="0"/>
+            <a:r>
+              <a:rPr lang="en-GB"/>
+              <a:t>Click to edit Master text styles</a:t>
+            </a:r>
+          </a:p>
+          <a:p>
+            <a:pPr lvl="1"/>
+            <a:r>
+              <a:rPr lang="en-GB"/>
+              <a:t>Second level</a:t>
+            </a:r>
+          </a:p>
+          <a:p>
+            <a:pPr lvl="2"/>
+            <a:r>
+              <a:rPr lang="en-GB"/>
+              <a:t>Third level</a:t>
+            </a:r>
+          </a:p>
+          <a:p>
+            <a:pPr lvl="3"/>
+            <a:r>
+              <a:rPr lang="en-GB"/>
+              <a:t>Fourth level</a:t>
+            </a:r>
+          </a:p>
+          <a:p>
+            <a:pPr lvl="4"/>
+            <a:r>
+              <a:rPr lang="en-GB"/>
+              <a:t>Fifth level</a:t>
+            </a:r>
+          </a:p>
+        </p:txBody>
+      </p:sp>
+      <p:sp>
+        <p:nvSpPr>
+          <p:cNvPr id="6" name="Footer Placeholder 5"/>
+          <p:cNvSpPr>
+            <a:spLocks noGrp="1"/>
+          </p:cNvSpPr>
+          <p:nvPr>
+            <p:ph type="ftr" sz="quarter" idx="4"/>
+          </p:nvPr>
+        </p:nvSpPr>
+        <p:spPr>
+          <a:xfrm>
+            <a:off x="0" y="8685213"/>
+            <a:ext cx="2971800" cy="458787"/>
+          </a:xfrm>
+          <a:prstGeom prst="rect">
+            <a:avLst/>
+          </a:prstGeom>
+        </p:spPr>
+        <p:txBody>
+          <a:bodyPr vert="horz" lIns="91440" tIns="45720" rIns="91440" bIns="45720" rtlCol="0" anchor="b"/>
+          <a:lstStyle>
+            <a:lvl1pPr algn="l">
+              <a:defRPr sz="1200"/>
+            </a:lvl1pPr>
+          </a:lstStyle>
+          <a:p>
+            <a:endParaRPr lang="en-GB"/>
+          </a:p>
+        </p:txBody>
+      </p:sp>
+      <p:sp>
+        <p:nvSpPr>
+          <p:cNvPr id="7" name="Slide Number Placeholder 6"/>
+          <p:cNvSpPr>
+            <a:spLocks noGrp="1"/>
+          </p:cNvSpPr>
+          <p:nvPr>
+            <p:ph type="sldNum" sz="quarter" idx="5"/>
+          </p:nvPr>
+        </p:nvSpPr>
+        <p:spPr>
+          <a:xfrm>
+            <a:off x="3884613" y="8685213"/>
+            <a:ext cx="2971800" cy="458787"/>
+          </a:xfrm>
+          <a:prstGeom prst="rect">
+            <a:avLst/>
+          </a:prstGeom>
+        </p:spPr>
+        <p:txBody>
+          <a:bodyPr vert="horz" lIns="91440" tIns="45720" rIns="91440" bIns="45720" rtlCol="0" anchor="b"/>
+          <a:lstStyle>
+            <a:lvl1pPr algn="r">
+              <a:defRPr sz="1200"/>
+            </a:lvl1pPr>
+          </a:lstStyle>
+          <a:p>
+            <a:fld id="{CCA1798E-80D5-4122-83EE-78F94422ED07}" type="slidenum">
+              <a:rPr lang="en-GB" smtClean="0"/>
+              <a:t>‹#›</a:t>
+            </a:fld>
+            <a:endParaRPr lang="en-GB"/>
+          </a:p>
+        </p:txBody>
+      </p:sp>
+    </p:spTree>
+    <p:extLst>
+      <p:ext uri="{BB962C8B-B14F-4D97-AF65-F5344CB8AC3E}">
+        <p14:creationId xmlns:p14="http://schemas.microsoft.com/office/powerpoint/2010/main" val="1467255259"/>
+      </p:ext>
+    </p:extLst>
+  </p:cSld>
+  <p:clrMap bg1="lt1" tx1="dk1" bg2="lt2" tx2="dk2" accent1="accent1" accent2="accent2" accent3="accent3" accent4="accent4" accent5="accent5" accent6="accent6" hlink="hlink" folHlink="folHlink"/>
+  <p:notesStyle>
+    <a:lvl1pPr marL="0" algn="l" defTabSz="914400" rtl="0" eaLnBrk="1" latinLnBrk="0" hangingPunct="1">
+      <a:defRPr sz="1200" kern="1200">
+        <a:solidFill>
+          <a:schemeClr val="tx1"/>
+        </a:solidFill>
+        <a:latin typeface="+mn-lt"/>
+        <a:ea typeface="+mn-ea"/>
+        <a:cs typeface="+mn-cs"/>
+      </a:defRPr>
+    </a:lvl1pPr>
+    <a:lvl2pPr marL="457200" algn="l" defTabSz="914400" rtl="0" eaLnBrk="1" latinLnBrk="0" hangingPunct="1">
+      <a:defRPr sz="1200" kern="1200">
+        <a:solidFill>
+          <a:schemeClr val="tx1"/>
+        </a:solidFill>
+        <a:latin typeface="+mn-lt"/>
+        <a:ea typeface="+mn-ea"/>
+        <a:cs typeface="+mn-cs"/>
+      </a:defRPr>
+    </a:lvl2pPr>
+    <a:lvl3pPr marL="914400" algn="l" defTabSz="914400" rtl="0" eaLnBrk="1" latinLnBrk="0" hangingPunct="1">
+      <a:defRPr sz="1200" kern="1200">
+        <a:solidFill>
+          <a:schemeClr val="tx1"/>
+        </a:solidFill>
+        <a:latin typeface="+mn-lt"/>
+        <a:ea typeface="+mn-ea"/>
+        <a:cs typeface="+mn-cs"/>
+      </a:defRPr>
+    </a:lvl3pPr>
+    <a:lvl4pPr marL="1371600" algn="l" defTabSz="914400" rtl="0" eaLnBrk="1" latinLnBrk="0" hangingPunct="1">
+      <a:defRPr sz="1200" kern="1200">
+        <a:solidFill>
+          <a:schemeClr val="tx1"/>
+        </a:solidFill>
+        <a:latin typeface="+mn-lt"/>
+        <a:ea typeface="+mn-ea"/>
+        <a:cs typeface="+mn-cs"/>
+      </a:defRPr>
+    </a:lvl4pPr>
+    <a:lvl5pPr marL="1828800" algn="l" defTabSz="914400" rtl="0" eaLnBrk="1" latinLnBrk="0" hangingPunct="1">
+      <a:defRPr sz="1200" kern="1200">
+        <a:solidFill>
+          <a:schemeClr val="tx1"/>
+        </a:solidFill>
+        <a:latin typeface="+mn-lt"/>
+        <a:ea typeface="+mn-ea"/>
+        <a:cs typeface="+mn-cs"/>
+      </a:defRPr>
+    </a:lvl5pPr>
+    <a:lvl6pPr marL="2286000" algn="l" defTabSz="914400" rtl="0" eaLnBrk="1" latinLnBrk="0" hangingPunct="1">
+      <a:defRPr sz="1200" kern="1200">
+        <a:solidFill>
+          <a:schemeClr val="tx1"/>
+        </a:solidFill>
+        <a:latin typeface="+mn-lt"/>
+        <a:ea typeface="+mn-ea"/>
+        <a:cs typeface="+mn-cs"/>
+      </a:defRPr>
+    </a:lvl6pPr>
+    <a:lvl7pPr marL="2743200" algn="l" defTabSz="914400" rtl="0" eaLnBrk="1" latinLnBrk="0" hangingPunct="1">
+      <a:defRPr sz="1200" kern="1200">
+        <a:solidFill>
+          <a:schemeClr val="tx1"/>
+        </a:solidFill>
+        <a:latin typeface="+mn-lt"/>
+        <a:ea typeface="+mn-ea"/>
+        <a:cs typeface="+mn-cs"/>
+      </a:defRPr>
+    </a:lvl7pPr>
+    <a:lvl8pPr marL="3200400" algn="l" defTabSz="914400" rtl="0" eaLnBrk="1" latinLnBrk="0" hangingPunct="1">
+      <a:defRPr sz="1200" kern="1200">
+        <a:solidFill>
+          <a:schemeClr val="tx1"/>
+        </a:solidFill>
+        <a:latin typeface="+mn-lt"/>
+        <a:ea typeface="+mn-ea"/>
+        <a:cs typeface="+mn-cs"/>
+      </a:defRPr>
+    </a:lvl8pPr>
+    <a:lvl9pPr marL="3657600" algn="l" defTabSz="914400" rtl="0" eaLnBrk="1" latinLnBrk="0" hangingPunct="1">
+      <a:defRPr sz="1200" kern="1200">
+        <a:solidFill>
+          <a:schemeClr val="tx1"/>
+        </a:solidFill>
+        <a:latin typeface="+mn-lt"/>
+        <a:ea typeface="+mn-ea"/>
+        <a:cs typeface="+mn-cs"/>
+      </a:defRPr>
+    </a:lvl9pPr>
+  </p:notesStyle>
+</p:notesMaster>
+</file>
+
+<file path=ppt/notesSlides/notesSlide1.xml><?xml version="1.0" encoding="utf-8"?>
+<p:notes xmlns:a="http://schemas.openxmlformats.org/drawingml/2006/main" xmlns:r="http://schemas.openxmlformats.org/officeDocument/2006/relationships" xmlns:p="http://schemas.openxmlformats.org/presentationml/2006/main">
+  <p:cSld>
+    <p:spTree>
+      <p:nvGrpSpPr>
+        <p:cNvPr id="1" name=""/>
+        <p:cNvGrpSpPr/>
+        <p:nvPr/>
+      </p:nvGrpSpPr>
+      <p:grpSpPr>
+        <a:xfrm>
+          <a:off x="0" y="0"/>
+          <a:ext cx="0" cy="0"/>
+          <a:chOff x="0" y="0"/>
+          <a:chExt cx="0" cy="0"/>
+        </a:xfrm>
+      </p:grpSpPr>
+      <p:sp>
+        <p:nvSpPr>
+          <p:cNvPr id="2" name="Slide Image Placeholder 1"/>
+          <p:cNvSpPr>
+            <a:spLocks noGrp="1" noRot="1" noChangeAspect="1"/>
+          </p:cNvSpPr>
+          <p:nvPr>
+            <p:ph type="sldImg"/>
+          </p:nvPr>
+        </p:nvSpPr>
+        <p:spPr/>
+      </p:sp>
+      <p:sp>
+        <p:nvSpPr>
+          <p:cNvPr id="3" name="Notes Placeholder 2"/>
+          <p:cNvSpPr>
+            <a:spLocks noGrp="1"/>
+          </p:cNvSpPr>
+          <p:nvPr>
+            <p:ph type="body" idx="1"/>
+          </p:nvPr>
+        </p:nvSpPr>
+        <p:spPr/>
+        <p:txBody>
+          <a:bodyPr/>
+          <a:lstStyle/>
+          <a:p>
+            <a:endParaRPr lang="en-GB" dirty="0"/>
+          </a:p>
+        </p:txBody>
+      </p:sp>
+      <p:sp>
+        <p:nvSpPr>
+          <p:cNvPr id="4" name="Slide Number Placeholder 3"/>
+          <p:cNvSpPr>
+            <a:spLocks noGrp="1"/>
+          </p:cNvSpPr>
+          <p:nvPr>
+            <p:ph type="sldNum" sz="quarter" idx="5"/>
+          </p:nvPr>
+        </p:nvSpPr>
+        <p:spPr/>
+        <p:txBody>
+          <a:bodyPr/>
+          <a:lstStyle/>
+          <a:p>
+            <a:fld id="{CCA1798E-80D5-4122-83EE-78F94422ED07}" type="slidenum">
+              <a:rPr lang="en-GB" smtClean="0"/>
+              <a:t>13</a:t>
+            </a:fld>
+            <a:endParaRPr lang="en-GB"/>
+          </a:p>
+        </p:txBody>
+      </p:sp>
+    </p:spTree>
+    <p:extLst>
+      <p:ext uri="{BB962C8B-B14F-4D97-AF65-F5344CB8AC3E}">
+        <p14:creationId xmlns:p14="http://schemas.microsoft.com/office/powerpoint/2010/main" val="2516706953"/>
+      </p:ext>
+    </p:extLst>
+  </p:cSld>
+  <p:clrMapOvr>
+    <a:masterClrMapping/>
+  </p:clrMapOvr>
+</p:notes>
 </file>
 
 <file path=ppt/slideLayouts/slideLayout1.xml><?xml version="1.0" encoding="utf-8"?>
@@ -8174,7 +8611,7 @@
           <a:p>
             <a:pPr algn="l"/>
             <a:r>
-              <a:rPr sz="3600" b="1" i="0">
+              <a:rPr sz="3600" b="1" i="0" dirty="0">
                 <a:solidFill>
                   <a:srgbClr val="FFFFFF"/>
                 </a:solidFill>
@@ -8616,6 +9053,18 @@
   <p:clrMapOvr>
     <a:masterClrMapping/>
   </p:clrMapOvr>
+  <mc:AlternateContent xmlns:mc="http://schemas.openxmlformats.org/markup-compatibility/2006">
+    <mc:Choice xmlns:p159="http://schemas.microsoft.com/office/powerpoint/2015/09/main" Requires="p159">
+      <p:transition xmlns:p14="http://schemas.microsoft.com/office/powerpoint/2010/main" spd="slow" p14:dur="2000">
+        <p159:morph option="byObject"/>
+      </p:transition>
+    </mc:Choice>
+    <mc:Fallback>
+      <p:transition spd="slow">
+        <p:fade/>
+      </p:transition>
+    </mc:Fallback>
+  </mc:AlternateContent>
 </p:sld>
 </file>
 
@@ -10006,6 +10455,18 @@
   <p:clrMapOvr>
     <a:masterClrMapping/>
   </p:clrMapOvr>
+  <mc:AlternateContent xmlns:mc="http://schemas.openxmlformats.org/markup-compatibility/2006">
+    <mc:Choice xmlns:p159="http://schemas.microsoft.com/office/powerpoint/2015/09/main" Requires="p159">
+      <p:transition xmlns:p14="http://schemas.microsoft.com/office/powerpoint/2010/main" spd="slow" p14:dur="2000">
+        <p159:morph option="byObject"/>
+      </p:transition>
+    </mc:Choice>
+    <mc:Fallback>
+      <p:transition spd="slow">
+        <p:fade/>
+      </p:transition>
+    </mc:Fallback>
+  </mc:AlternateContent>
 </p:sld>
 </file>
 
@@ -12166,6 +12627,18 @@
   <p:clrMapOvr>
     <a:masterClrMapping/>
   </p:clrMapOvr>
+  <mc:AlternateContent xmlns:mc="http://schemas.openxmlformats.org/markup-compatibility/2006">
+    <mc:Choice xmlns:p159="http://schemas.microsoft.com/office/powerpoint/2015/09/main" Requires="p159">
+      <p:transition xmlns:p14="http://schemas.microsoft.com/office/powerpoint/2010/main" spd="slow" p14:dur="2000">
+        <p159:morph option="byObject"/>
+      </p:transition>
+    </mc:Choice>
+    <mc:Fallback>
+      <p:transition spd="slow">
+        <p:fade/>
+      </p:transition>
+    </mc:Fallback>
+  </mc:AlternateContent>
 </p:sld>
 </file>
 
@@ -13271,6 +13744,18 @@
   <p:clrMapOvr>
     <a:masterClrMapping/>
   </p:clrMapOvr>
+  <mc:AlternateContent xmlns:mc="http://schemas.openxmlformats.org/markup-compatibility/2006">
+    <mc:Choice xmlns:p159="http://schemas.microsoft.com/office/powerpoint/2015/09/main" Requires="p159">
+      <p:transition xmlns:p14="http://schemas.microsoft.com/office/powerpoint/2010/main" spd="slow" p14:dur="2000">
+        <p159:morph option="byObject"/>
+      </p:transition>
+    </mc:Choice>
+    <mc:Fallback>
+      <p:transition spd="slow">
+        <p:fade/>
+      </p:transition>
+    </mc:Fallback>
+  </mc:AlternateContent>
 </p:sld>
 </file>
 
@@ -15564,11 +16049,267 @@
           </a:p>
         </p:txBody>
       </p:sp>
+      <p:sp>
+        <p:nvSpPr>
+          <p:cNvPr id="37" name="TextBox 36">
+            <a:extLst>
+              <a:ext uri="{FF2B5EF4-FFF2-40B4-BE49-F238E27FC236}">
+                <a16:creationId xmlns:a16="http://schemas.microsoft.com/office/drawing/2014/main" id="{E34FC717-CDB3-266F-04C2-324797331F37}"/>
+              </a:ext>
+            </a:extLst>
+          </p:cNvPr>
+          <p:cNvSpPr txBox="1"/>
+          <p:nvPr/>
+        </p:nvSpPr>
+        <p:spPr>
+          <a:xfrm>
+            <a:off x="12264390" y="1259175"/>
+            <a:ext cx="7703820" cy="2215991"/>
+          </a:xfrm>
+          <a:prstGeom prst="rect">
+            <a:avLst/>
+          </a:prstGeom>
+          <a:noFill/>
+        </p:spPr>
+        <p:txBody>
+          <a:bodyPr wrap="square">
+            <a:spAutoFit/>
+          </a:bodyPr>
+          <a:lstStyle/>
+          <a:p>
+            <a:pPr algn="l"/>
+            <a:r>
+              <a:rPr lang="es-BO" sz="13800" b="1" i="0" dirty="0">
+                <a:solidFill>
+                  <a:srgbClr val="FFFFFF"/>
+                </a:solidFill>
+                <a:latin typeface="Cambria"/>
+              </a:rPr>
+              <a:t>MUCHAS</a:t>
+            </a:r>
+            <a:endParaRPr sz="13800" b="1" i="0" dirty="0">
+              <a:solidFill>
+                <a:srgbClr val="FFFFFF"/>
+              </a:solidFill>
+              <a:latin typeface="Cambria"/>
+            </a:endParaRPr>
+          </a:p>
+        </p:txBody>
+      </p:sp>
+      <p:sp>
+        <p:nvSpPr>
+          <p:cNvPr id="38" name="TextBox 37">
+            <a:extLst>
+              <a:ext uri="{FF2B5EF4-FFF2-40B4-BE49-F238E27FC236}">
+                <a16:creationId xmlns:a16="http://schemas.microsoft.com/office/drawing/2014/main" id="{61E1830A-1AA2-7894-BF34-7F10D6C98854}"/>
+              </a:ext>
+            </a:extLst>
+          </p:cNvPr>
+          <p:cNvSpPr txBox="1"/>
+          <p:nvPr/>
+        </p:nvSpPr>
+        <p:spPr>
+          <a:xfrm>
+            <a:off x="-7299960" y="3382834"/>
+            <a:ext cx="7703820" cy="2215991"/>
+          </a:xfrm>
+          <a:prstGeom prst="rect">
+            <a:avLst/>
+          </a:prstGeom>
+          <a:noFill/>
+        </p:spPr>
+        <p:txBody>
+          <a:bodyPr wrap="square">
+            <a:spAutoFit/>
+          </a:bodyPr>
+          <a:lstStyle/>
+          <a:p>
+            <a:pPr algn="l"/>
+            <a:r>
+              <a:rPr lang="es-BO" sz="13800" b="1" i="0" dirty="0">
+                <a:solidFill>
+                  <a:srgbClr val="FFFFFF"/>
+                </a:solidFill>
+                <a:latin typeface="Cambria"/>
+              </a:rPr>
+              <a:t>GRACIAS</a:t>
+            </a:r>
+            <a:endParaRPr sz="13800" b="1" i="0" dirty="0">
+              <a:solidFill>
+                <a:srgbClr val="FFFFFF"/>
+              </a:solidFill>
+              <a:latin typeface="Cambria"/>
+            </a:endParaRPr>
+          </a:p>
+        </p:txBody>
+      </p:sp>
     </p:spTree>
   </p:cSld>
   <p:clrMapOvr>
     <a:masterClrMapping/>
   </p:clrMapOvr>
+  <mc:AlternateContent xmlns:mc="http://schemas.openxmlformats.org/markup-compatibility/2006">
+    <mc:Choice xmlns:p159="http://schemas.microsoft.com/office/powerpoint/2015/09/main" Requires="p159">
+      <p:transition xmlns:p14="http://schemas.microsoft.com/office/powerpoint/2010/main" spd="slow" p14:dur="2000">
+        <p159:morph option="byObject"/>
+      </p:transition>
+    </mc:Choice>
+    <mc:Fallback>
+      <p:transition spd="slow">
+        <p:fade/>
+      </p:transition>
+    </mc:Fallback>
+  </mc:AlternateContent>
+</p:sld>
+</file>
+
+<file path=ppt/slides/slide14.xml><?xml version="1.0" encoding="utf-8"?>
+<p:sld xmlns:a="http://schemas.openxmlformats.org/drawingml/2006/main" xmlns:r="http://schemas.openxmlformats.org/officeDocument/2006/relationships" xmlns:p="http://schemas.openxmlformats.org/presentationml/2006/main">
+  <p:cSld>
+    <p:bg>
+      <p:bgPr>
+        <a:solidFill>
+          <a:srgbClr val="0B0F1A"/>
+        </a:solidFill>
+        <a:effectLst/>
+      </p:bgPr>
+    </p:bg>
+    <p:spTree>
+      <p:nvGrpSpPr>
+        <p:cNvPr id="1" name="">
+          <a:extLst>
+            <a:ext uri="{FF2B5EF4-FFF2-40B4-BE49-F238E27FC236}">
+              <a16:creationId xmlns:a16="http://schemas.microsoft.com/office/drawing/2014/main" id="{54722AE8-8240-F3D6-6F00-DB7F08624682}"/>
+            </a:ext>
+          </a:extLst>
+        </p:cNvPr>
+        <p:cNvGrpSpPr/>
+        <p:nvPr/>
+      </p:nvGrpSpPr>
+      <p:grpSpPr>
+        <a:xfrm>
+          <a:off x="0" y="0"/>
+          <a:ext cx="0" cy="0"/>
+          <a:chOff x="0" y="0"/>
+          <a:chExt cx="0" cy="0"/>
+        </a:xfrm>
+      </p:grpSpPr>
+      <p:sp>
+        <p:nvSpPr>
+          <p:cNvPr id="37" name="TextBox 36">
+            <a:extLst>
+              <a:ext uri="{FF2B5EF4-FFF2-40B4-BE49-F238E27FC236}">
+                <a16:creationId xmlns:a16="http://schemas.microsoft.com/office/drawing/2014/main" id="{C3470461-F8DA-47FD-36B6-495EB1942025}"/>
+              </a:ext>
+            </a:extLst>
+          </p:cNvPr>
+          <p:cNvSpPr txBox="1"/>
+          <p:nvPr/>
+        </p:nvSpPr>
+        <p:spPr>
+          <a:xfrm>
+            <a:off x="2244090" y="1259175"/>
+            <a:ext cx="7703820" cy="2215991"/>
+          </a:xfrm>
+          <a:prstGeom prst="rect">
+            <a:avLst/>
+          </a:prstGeom>
+          <a:noFill/>
+        </p:spPr>
+        <p:txBody>
+          <a:bodyPr wrap="square">
+            <a:spAutoFit/>
+          </a:bodyPr>
+          <a:lstStyle/>
+          <a:p>
+            <a:pPr algn="l"/>
+            <a:r>
+              <a:rPr lang="es-BO" sz="13800" b="1" i="0" dirty="0">
+                <a:solidFill>
+                  <a:srgbClr val="FFFFFF"/>
+                </a:solidFill>
+                <a:latin typeface="Cambria"/>
+              </a:rPr>
+              <a:t>MUCHAS</a:t>
+            </a:r>
+            <a:endParaRPr sz="13800" b="1" i="0" dirty="0">
+              <a:solidFill>
+                <a:srgbClr val="FFFFFF"/>
+              </a:solidFill>
+              <a:latin typeface="Cambria"/>
+            </a:endParaRPr>
+          </a:p>
+        </p:txBody>
+      </p:sp>
+      <p:sp>
+        <p:nvSpPr>
+          <p:cNvPr id="38" name="TextBox 37">
+            <a:extLst>
+              <a:ext uri="{FF2B5EF4-FFF2-40B4-BE49-F238E27FC236}">
+                <a16:creationId xmlns:a16="http://schemas.microsoft.com/office/drawing/2014/main" id="{5B043AAF-009D-F6E8-FC7B-2EB0E6FD12AE}"/>
+              </a:ext>
+            </a:extLst>
+          </p:cNvPr>
+          <p:cNvSpPr txBox="1"/>
+          <p:nvPr/>
+        </p:nvSpPr>
+        <p:spPr>
+          <a:xfrm>
+            <a:off x="2244090" y="3382834"/>
+            <a:ext cx="7703820" cy="2215991"/>
+          </a:xfrm>
+          <a:prstGeom prst="rect">
+            <a:avLst/>
+          </a:prstGeom>
+          <a:noFill/>
+        </p:spPr>
+        <p:txBody>
+          <a:bodyPr wrap="square">
+            <a:spAutoFit/>
+          </a:bodyPr>
+          <a:lstStyle/>
+          <a:p>
+            <a:pPr algn="l"/>
+            <a:r>
+              <a:rPr lang="es-BO" sz="13800" b="1" i="0" dirty="0">
+                <a:solidFill>
+                  <a:srgbClr val="FFFFFF"/>
+                </a:solidFill>
+                <a:latin typeface="Cambria"/>
+              </a:rPr>
+              <a:t>GRACIAS</a:t>
+            </a:r>
+            <a:endParaRPr sz="13800" b="1" i="0" dirty="0">
+              <a:solidFill>
+                <a:srgbClr val="FFFFFF"/>
+              </a:solidFill>
+              <a:latin typeface="Cambria"/>
+            </a:endParaRPr>
+          </a:p>
+        </p:txBody>
+      </p:sp>
+    </p:spTree>
+    <p:extLst>
+      <p:ext uri="{BB962C8B-B14F-4D97-AF65-F5344CB8AC3E}">
+        <p14:creationId xmlns:p14="http://schemas.microsoft.com/office/powerpoint/2010/main" val="1304775158"/>
+      </p:ext>
+    </p:extLst>
+  </p:cSld>
+  <p:clrMapOvr>
+    <a:masterClrMapping/>
+  </p:clrMapOvr>
+  <mc:AlternateContent xmlns:mc="http://schemas.openxmlformats.org/markup-compatibility/2006">
+    <mc:Choice xmlns:p159="http://schemas.microsoft.com/office/powerpoint/2015/09/main" Requires="p159">
+      <p:transition xmlns:p14="http://schemas.microsoft.com/office/powerpoint/2010/main" spd="slow" p14:dur="2000">
+        <p159:morph option="byObject"/>
+      </p:transition>
+    </mc:Choice>
+    <mc:Fallback>
+      <p:transition spd="slow">
+        <p:fade/>
+      </p:transition>
+    </mc:Fallback>
+  </mc:AlternateContent>
 </p:sld>
 </file>
 
@@ -17853,6 +18594,18 @@
   <p:clrMapOvr>
     <a:masterClrMapping/>
   </p:clrMapOvr>
+  <mc:AlternateContent xmlns:mc="http://schemas.openxmlformats.org/markup-compatibility/2006">
+    <mc:Choice xmlns:p159="http://schemas.microsoft.com/office/powerpoint/2015/09/main" Requires="p159">
+      <p:transition xmlns:p14="http://schemas.microsoft.com/office/powerpoint/2010/main" spd="slow" p14:dur="2000">
+        <p159:morph option="byObject"/>
+      </p:transition>
+    </mc:Choice>
+    <mc:Fallback>
+      <p:transition spd="slow">
+        <p:fade/>
+      </p:transition>
+    </mc:Fallback>
+  </mc:AlternateContent>
 </p:sld>
 </file>
 
@@ -19105,6 +19858,18 @@
   <p:clrMapOvr>
     <a:masterClrMapping/>
   </p:clrMapOvr>
+  <mc:AlternateContent xmlns:mc="http://schemas.openxmlformats.org/markup-compatibility/2006">
+    <mc:Choice xmlns:p159="http://schemas.microsoft.com/office/powerpoint/2015/09/main" Requires="p159">
+      <p:transition xmlns:p14="http://schemas.microsoft.com/office/powerpoint/2010/main" spd="slow" p14:dur="2000">
+        <p159:morph option="byObject"/>
+      </p:transition>
+    </mc:Choice>
+    <mc:Fallback>
+      <p:transition spd="slow">
+        <p:fade/>
+      </p:transition>
+    </mc:Fallback>
+  </mc:AlternateContent>
 </p:sld>
 </file>
 
@@ -19536,8 +20301,8 @@
           </p:txBody>
         </p:sp>
       </p:grpSp>
-      <mc:AlternateContent xmlns:mc="http://schemas.openxmlformats.org/markup-compatibility/2006">
-        <mc:Choice xmlns:a14="http://schemas.microsoft.com/office/drawing/2010/main" Requires="a14">
+      <mc:AlternateContent xmlns:mc="http://schemas.openxmlformats.org/markup-compatibility/2006" xmlns:a14="http://schemas.microsoft.com/office/drawing/2010/main">
+        <mc:Choice Requires="a14">
           <p:sp>
             <p:nvSpPr>
               <p:cNvPr id="11" name="TextBox 10"/>
@@ -19683,7 +20448,7 @@
             </p:txBody>
           </p:sp>
         </mc:Choice>
-        <mc:Fallback>
+        <mc:Fallback xmlns="">
           <p:sp>
             <p:nvSpPr>
               <p:cNvPr id="11" name="TextBox 10"/>
@@ -19822,8 +20587,8 @@
           </p:txBody>
         </p:sp>
       </p:grpSp>
-      <mc:AlternateContent xmlns:mc="http://schemas.openxmlformats.org/markup-compatibility/2006">
-        <mc:Choice xmlns:a14="http://schemas.microsoft.com/office/drawing/2010/main" Requires="a14">
+      <mc:AlternateContent xmlns:mc="http://schemas.openxmlformats.org/markup-compatibility/2006" xmlns:a14="http://schemas.microsoft.com/office/drawing/2010/main">
+        <mc:Choice Requires="a14">
           <p:sp>
             <p:nvSpPr>
               <p:cNvPr id="14" name="TextBox 13"/>
@@ -19942,7 +20707,7 @@
             </p:txBody>
           </p:sp>
         </mc:Choice>
-        <mc:Fallback>
+        <mc:Fallback xmlns="">
           <p:sp>
             <p:nvSpPr>
               <p:cNvPr id="14" name="TextBox 13"/>
@@ -20365,8 +21130,8 @@
             </a:p>
           </p:txBody>
         </p:sp>
-        <mc:AlternateContent xmlns:mc="http://schemas.openxmlformats.org/markup-compatibility/2006">
-          <mc:Choice xmlns:a14="http://schemas.microsoft.com/office/drawing/2010/main" Requires="a14">
+        <mc:AlternateContent xmlns:mc="http://schemas.openxmlformats.org/markup-compatibility/2006" xmlns:a14="http://schemas.microsoft.com/office/drawing/2010/main">
+          <mc:Choice Requires="a14">
             <p:sp>
               <p:nvSpPr>
                 <p:cNvPr id="23" name="TextBox 22"/>
@@ -20595,7 +21360,7 @@
               </p:txBody>
             </p:sp>
           </mc:Choice>
-          <mc:Fallback>
+          <mc:Fallback xmlns="">
             <p:sp>
               <p:nvSpPr>
                 <p:cNvPr id="23" name="TextBox 22"/>
@@ -20634,8 +21399,8 @@
             </p:sp>
           </mc:Fallback>
         </mc:AlternateContent>
-        <mc:AlternateContent xmlns:mc="http://schemas.openxmlformats.org/markup-compatibility/2006">
-          <mc:Choice xmlns:a14="http://schemas.microsoft.com/office/drawing/2010/main" Requires="a14">
+        <mc:AlternateContent xmlns:mc="http://schemas.openxmlformats.org/markup-compatibility/2006" xmlns:a14="http://schemas.microsoft.com/office/drawing/2010/main">
+          <mc:Choice Requires="a14">
             <p:sp>
               <p:nvSpPr>
                 <p:cNvPr id="24" name="TextBox 23"/>
@@ -20725,7 +21490,7 @@
               </p:txBody>
             </p:sp>
           </mc:Choice>
-          <mc:Fallback>
+          <mc:Fallback xmlns="">
             <p:sp>
               <p:nvSpPr>
                 <p:cNvPr id="24" name="TextBox 23"/>
@@ -20764,8 +21529,8 @@
             </p:sp>
           </mc:Fallback>
         </mc:AlternateContent>
-        <mc:AlternateContent xmlns:mc="http://schemas.openxmlformats.org/markup-compatibility/2006">
-          <mc:Choice xmlns:a14="http://schemas.microsoft.com/office/drawing/2010/main" Requires="a14">
+        <mc:AlternateContent xmlns:mc="http://schemas.openxmlformats.org/markup-compatibility/2006" xmlns:a14="http://schemas.microsoft.com/office/drawing/2010/main">
+          <mc:Choice Requires="a14">
             <p:sp>
               <p:nvSpPr>
                 <p:cNvPr id="25" name="TextBox 24"/>
@@ -20864,7 +21629,7 @@
               </p:txBody>
             </p:sp>
           </mc:Choice>
-          <mc:Fallback>
+          <mc:Fallback xmlns="">
             <p:sp>
               <p:nvSpPr>
                 <p:cNvPr id="25" name="TextBox 24"/>
@@ -20959,8 +21724,8 @@
             </a:p>
           </p:txBody>
         </p:sp>
-        <mc:AlternateContent xmlns:mc="http://schemas.openxmlformats.org/markup-compatibility/2006">
-          <mc:Choice xmlns:a14="http://schemas.microsoft.com/office/drawing/2010/main" Requires="a14">
+        <mc:AlternateContent xmlns:mc="http://schemas.openxmlformats.org/markup-compatibility/2006" xmlns:a14="http://schemas.microsoft.com/office/drawing/2010/main">
+          <mc:Choice Requires="a14">
             <p:sp>
               <p:nvSpPr>
                 <p:cNvPr id="27" name="TextBox 26"/>
@@ -21247,7 +22012,7 @@
               </p:txBody>
             </p:sp>
           </mc:Choice>
-          <mc:Fallback>
+          <mc:Fallback xmlns="">
             <p:sp>
               <p:nvSpPr>
                 <p:cNvPr id="27" name="TextBox 26"/>
@@ -21286,8 +22051,8 @@
             </p:sp>
           </mc:Fallback>
         </mc:AlternateContent>
-        <mc:AlternateContent xmlns:mc="http://schemas.openxmlformats.org/markup-compatibility/2006">
-          <mc:Choice xmlns:a14="http://schemas.microsoft.com/office/drawing/2010/main" Requires="a14">
+        <mc:AlternateContent xmlns:mc="http://schemas.openxmlformats.org/markup-compatibility/2006" xmlns:a14="http://schemas.microsoft.com/office/drawing/2010/main">
+          <mc:Choice Requires="a14">
             <p:sp>
               <p:nvSpPr>
                 <p:cNvPr id="28" name="TextBox 27"/>
@@ -21407,7 +22172,7 @@
               </p:txBody>
             </p:sp>
           </mc:Choice>
-          <mc:Fallback>
+          <mc:Fallback xmlns="">
             <p:sp>
               <p:nvSpPr>
                 <p:cNvPr id="28" name="TextBox 27"/>
@@ -21446,8 +22211,8 @@
             </p:sp>
           </mc:Fallback>
         </mc:AlternateContent>
-        <mc:AlternateContent xmlns:mc="http://schemas.openxmlformats.org/markup-compatibility/2006">
-          <mc:Choice xmlns:a14="http://schemas.microsoft.com/office/drawing/2010/main" Requires="a14">
+        <mc:AlternateContent xmlns:mc="http://schemas.openxmlformats.org/markup-compatibility/2006" xmlns:a14="http://schemas.microsoft.com/office/drawing/2010/main">
+          <mc:Choice Requires="a14">
             <p:sp>
               <p:nvSpPr>
                 <p:cNvPr id="29" name="TextBox 28"/>
@@ -21582,7 +22347,7 @@
               </p:txBody>
             </p:sp>
           </mc:Choice>
-          <mc:Fallback>
+          <mc:Fallback xmlns="">
             <p:sp>
               <p:nvSpPr>
                 <p:cNvPr id="29" name="TextBox 28"/>
@@ -21677,8 +22442,8 @@
             </a:p>
           </p:txBody>
         </p:sp>
-        <mc:AlternateContent xmlns:mc="http://schemas.openxmlformats.org/markup-compatibility/2006">
-          <mc:Choice xmlns:a14="http://schemas.microsoft.com/office/drawing/2010/main" Requires="a14">
+        <mc:AlternateContent xmlns:mc="http://schemas.openxmlformats.org/markup-compatibility/2006" xmlns:a14="http://schemas.microsoft.com/office/drawing/2010/main">
+          <mc:Choice Requires="a14">
             <p:sp>
               <p:nvSpPr>
                 <p:cNvPr id="31" name="TextBox 30"/>
@@ -21868,7 +22633,7 @@
               </p:txBody>
             </p:sp>
           </mc:Choice>
-          <mc:Fallback>
+          <mc:Fallback xmlns="">
             <p:sp>
               <p:nvSpPr>
                 <p:cNvPr id="31" name="TextBox 30"/>
@@ -21907,8 +22672,8 @@
             </p:sp>
           </mc:Fallback>
         </mc:AlternateContent>
-        <mc:AlternateContent xmlns:mc="http://schemas.openxmlformats.org/markup-compatibility/2006">
-          <mc:Choice xmlns:a14="http://schemas.microsoft.com/office/drawing/2010/main" Requires="a14">
+        <mc:AlternateContent xmlns:mc="http://schemas.openxmlformats.org/markup-compatibility/2006" xmlns:a14="http://schemas.microsoft.com/office/drawing/2010/main">
+          <mc:Choice Requires="a14">
             <p:sp>
               <p:nvSpPr>
                 <p:cNvPr id="32" name="TextBox 31"/>
@@ -21976,7 +22741,7 @@
               </p:txBody>
             </p:sp>
           </mc:Choice>
-          <mc:Fallback>
+          <mc:Fallback xmlns="">
             <p:sp>
               <p:nvSpPr>
                 <p:cNvPr id="32" name="TextBox 31"/>
@@ -22286,8 +23051,8 @@
             </a:p>
           </p:txBody>
         </p:sp>
-        <mc:AlternateContent xmlns:mc="http://schemas.openxmlformats.org/markup-compatibility/2006">
-          <mc:Choice xmlns:a14="http://schemas.microsoft.com/office/drawing/2010/main" Requires="a14">
+        <mc:AlternateContent xmlns:mc="http://schemas.openxmlformats.org/markup-compatibility/2006" xmlns:a14="http://schemas.microsoft.com/office/drawing/2010/main">
+          <mc:Choice Requires="a14">
             <p:sp>
               <p:nvSpPr>
                 <p:cNvPr id="39" name="TextBox 38"/>
@@ -22424,11 +23189,12 @@
                       </m:oMath>
                     </m:oMathPara>
                   </a14:m>
+                  <a:endParaRPr/>
                 </a:p>
               </p:txBody>
             </p:sp>
           </mc:Choice>
-          <mc:Fallback>
+          <mc:Fallback xmlns="">
             <p:sp>
               <p:nvSpPr>
                 <p:cNvPr id="39" name="TextBox 38"/>
@@ -22710,8 +23476,8 @@
             </a:p>
           </p:txBody>
         </p:sp>
-        <mc:AlternateContent xmlns:mc="http://schemas.openxmlformats.org/markup-compatibility/2006">
-          <mc:Choice xmlns:a14="http://schemas.microsoft.com/office/drawing/2010/main" Requires="a14">
+        <mc:AlternateContent xmlns:mc="http://schemas.openxmlformats.org/markup-compatibility/2006" xmlns:a14="http://schemas.microsoft.com/office/drawing/2010/main">
+          <mc:Choice Requires="a14">
             <p:sp>
               <p:nvSpPr>
                 <p:cNvPr id="43" name="TextBox 42"/>
@@ -22888,11 +23654,12 @@
                       </m:oMath>
                     </m:oMathPara>
                   </a14:m>
+                  <a:endParaRPr/>
                 </a:p>
               </p:txBody>
             </p:sp>
           </mc:Choice>
-          <mc:Fallback>
+          <mc:Fallback xmlns="">
             <p:sp>
               <p:nvSpPr>
                 <p:cNvPr id="43" name="TextBox 42"/>
@@ -23066,8 +23833,8 @@
             </a:p>
           </p:txBody>
         </p:sp>
-        <mc:AlternateContent xmlns:mc="http://schemas.openxmlformats.org/markup-compatibility/2006">
-          <mc:Choice xmlns:a14="http://schemas.microsoft.com/office/drawing/2010/main" Requires="a14">
+        <mc:AlternateContent xmlns:mc="http://schemas.openxmlformats.org/markup-compatibility/2006" xmlns:a14="http://schemas.microsoft.com/office/drawing/2010/main">
+          <mc:Choice Requires="a14">
             <p:sp>
               <p:nvSpPr>
                 <p:cNvPr id="47" name="TextBox 46"/>
@@ -23238,11 +24005,12 @@
                       </m:oMath>
                     </m:oMathPara>
                   </a14:m>
+                  <a:endParaRPr/>
                 </a:p>
               </p:txBody>
             </p:sp>
           </mc:Choice>
-          <mc:Fallback>
+          <mc:Fallback xmlns="">
             <p:sp>
               <p:nvSpPr>
                 <p:cNvPr id="47" name="TextBox 46"/>
@@ -23476,8 +24244,8 @@
             </a:p>
           </p:txBody>
         </p:sp>
-        <mc:AlternateContent xmlns:mc="http://schemas.openxmlformats.org/markup-compatibility/2006">
-          <mc:Choice xmlns:a14="http://schemas.microsoft.com/office/drawing/2010/main" Requires="a14">
+        <mc:AlternateContent xmlns:mc="http://schemas.openxmlformats.org/markup-compatibility/2006" xmlns:a14="http://schemas.microsoft.com/office/drawing/2010/main">
+          <mc:Choice Requires="a14">
             <p:sp>
               <p:nvSpPr>
                 <p:cNvPr id="51" name="TextBox 50"/>
@@ -23596,11 +24364,12 @@
                       </m:oMath>
                     </m:oMathPara>
                   </a14:m>
+                  <a:endParaRPr/>
                 </a:p>
               </p:txBody>
             </p:sp>
           </mc:Choice>
-          <mc:Fallback>
+          <mc:Fallback xmlns="">
             <p:sp>
               <p:nvSpPr>
                 <p:cNvPr id="51" name="TextBox 50"/>
@@ -23780,6 +24549,18 @@
   <p:clrMapOvr>
     <a:masterClrMapping/>
   </p:clrMapOvr>
+  <mc:AlternateContent xmlns:mc="http://schemas.openxmlformats.org/markup-compatibility/2006">
+    <mc:Choice xmlns:p159="http://schemas.microsoft.com/office/powerpoint/2015/09/main" Requires="p159">
+      <p:transition xmlns:p14="http://schemas.microsoft.com/office/powerpoint/2010/main" spd="slow" p14:dur="2000">
+        <p159:morph option="byObject"/>
+      </p:transition>
+    </mc:Choice>
+    <mc:Fallback>
+      <p:transition spd="slow">
+        <p:fade/>
+      </p:transition>
+    </mc:Fallback>
+  </mc:AlternateContent>
 </p:sld>
 </file>
 
@@ -24059,8 +24840,8 @@
           </a:p>
         </p:txBody>
       </p:sp>
-      <mc:AlternateContent xmlns:mc="http://schemas.openxmlformats.org/markup-compatibility/2006">
-        <mc:Choice xmlns:a14="http://schemas.microsoft.com/office/drawing/2010/main" Requires="a14">
+      <mc:AlternateContent xmlns:mc="http://schemas.openxmlformats.org/markup-compatibility/2006" xmlns:a14="http://schemas.microsoft.com/office/drawing/2010/main">
+        <mc:Choice Requires="a14">
           <p:sp>
             <p:nvSpPr>
               <p:cNvPr id="7" name="TextBox 6"/>
@@ -24444,11 +25225,12 @@
                     </m:oMath>
                   </m:oMathPara>
                 </a14:m>
+                <a:endParaRPr/>
               </a:p>
             </p:txBody>
           </p:sp>
         </mc:Choice>
-        <mc:Fallback>
+        <mc:Fallback xmlns="">
           <p:sp>
             <p:nvSpPr>
               <p:cNvPr id="7" name="TextBox 6"/>
@@ -24649,8 +25431,8 @@
           </a:p>
         </p:txBody>
       </p:sp>
-      <mc:AlternateContent xmlns:mc="http://schemas.openxmlformats.org/markup-compatibility/2006">
-        <mc:Choice xmlns:a14="http://schemas.microsoft.com/office/drawing/2010/main" Requires="a14">
+      <mc:AlternateContent xmlns:mc="http://schemas.openxmlformats.org/markup-compatibility/2006" xmlns:a14="http://schemas.microsoft.com/office/drawing/2010/main">
+        <mc:Choice Requires="a14">
           <p:sp>
             <p:nvSpPr>
               <p:cNvPr id="12" name="TextBox 11"/>
@@ -24819,11 +25601,12 @@
                     </m:oMath>
                   </m:oMathPara>
                 </a14:m>
+                <a:endParaRPr/>
               </a:p>
             </p:txBody>
           </p:sp>
         </mc:Choice>
-        <mc:Fallback>
+        <mc:Fallback xmlns="">
           <p:sp>
             <p:nvSpPr>
               <p:cNvPr id="12" name="TextBox 11"/>
@@ -24862,8 +25645,8 @@
           </p:sp>
         </mc:Fallback>
       </mc:AlternateContent>
-      <mc:AlternateContent xmlns:mc="http://schemas.openxmlformats.org/markup-compatibility/2006">
-        <mc:Choice xmlns:a14="http://schemas.microsoft.com/office/drawing/2010/main" Requires="a14">
+      <mc:AlternateContent xmlns:mc="http://schemas.openxmlformats.org/markup-compatibility/2006" xmlns:a14="http://schemas.microsoft.com/office/drawing/2010/main">
+        <mc:Choice Requires="a14">
           <p:sp>
             <p:nvSpPr>
               <p:cNvPr id="13" name="TextBox 12"/>
@@ -25244,7 +26027,7 @@
             </p:txBody>
           </p:sp>
         </mc:Choice>
-        <mc:Fallback>
+        <mc:Fallback xmlns="">
           <p:sp>
             <p:nvSpPr>
               <p:cNvPr id="13" name="TextBox 12"/>
@@ -25480,8 +26263,8 @@
           </a:p>
         </p:txBody>
       </p:sp>
-      <mc:AlternateContent xmlns:mc="http://schemas.openxmlformats.org/markup-compatibility/2006">
-        <mc:Choice xmlns:a14="http://schemas.microsoft.com/office/drawing/2010/main" Requires="a14">
+      <mc:AlternateContent xmlns:mc="http://schemas.openxmlformats.org/markup-compatibility/2006" xmlns:a14="http://schemas.microsoft.com/office/drawing/2010/main">
+        <mc:Choice Requires="a14">
           <p:sp>
             <p:nvSpPr>
               <p:cNvPr id="19" name="TextBox 18"/>
@@ -25711,11 +26494,12 @@
                     </m:oMath>
                   </m:oMathPara>
                 </a14:m>
+                <a:endParaRPr/>
               </a:p>
             </p:txBody>
           </p:sp>
         </mc:Choice>
-        <mc:Fallback>
+        <mc:Fallback xmlns="">
           <p:sp>
             <p:nvSpPr>
               <p:cNvPr id="19" name="TextBox 18"/>
@@ -25864,6 +26648,18 @@
   <p:clrMapOvr>
     <a:masterClrMapping/>
   </p:clrMapOvr>
+  <mc:AlternateContent xmlns:mc="http://schemas.openxmlformats.org/markup-compatibility/2006">
+    <mc:Choice xmlns:p159="http://schemas.microsoft.com/office/powerpoint/2015/09/main" Requires="p159">
+      <p:transition xmlns:p14="http://schemas.microsoft.com/office/powerpoint/2010/main" spd="slow" p14:dur="2000">
+        <p159:morph option="byObject"/>
+      </p:transition>
+    </mc:Choice>
+    <mc:Fallback>
+      <p:transition spd="slow">
+        <p:fade/>
+      </p:transition>
+    </mc:Fallback>
+  </mc:AlternateContent>
 </p:sld>
 </file>
 
@@ -26247,8 +27043,8 @@
           </a:p>
         </p:txBody>
       </p:sp>
-      <mc:AlternateContent xmlns:mc="http://schemas.openxmlformats.org/markup-compatibility/2006">
-        <mc:Choice xmlns:a14="http://schemas.microsoft.com/office/drawing/2010/main" Requires="a14">
+      <mc:AlternateContent xmlns:mc="http://schemas.openxmlformats.org/markup-compatibility/2006" xmlns:a14="http://schemas.microsoft.com/office/drawing/2010/main">
+        <mc:Choice Requires="a14">
           <p:sp>
             <p:nvSpPr>
               <p:cNvPr id="11" name="TextBox 10"/>
@@ -26273,101 +27069,6 @@
               <a:p>
                 <a:pPr algn="l"/>
                 <a14:m>
-                  <m:oMathPara xmlns:m="http://schemas.openxmlformats.org/officeDocument/2006/math">
-                    <m:oMathParaPr>
-                      <m:jc m:val="centerGroup"/>
-                    </m:oMathParaPr>
-                    <m:oMath xmlns:m="http://schemas.openxmlformats.org/officeDocument/2006/math">
-                      <m:r>
-                        <a:rPr lang="en-GB" sz="1050" b="1" i="0" dirty="0" smtClean="0">
-                          <a:solidFill>
-                            <a:srgbClr val="3B82F6"/>
-                          </a:solidFill>
-                          <a:latin typeface="Cambria Math" panose="02040503050406030204" pitchFamily="18" charset="0"/>
-                        </a:rPr>
-                        <m:t>𝚺</m:t>
-                      </m:r>
-                      <m:r>
-                        <a:rPr lang="en-GB" sz="1050" b="1" i="1" dirty="0">
-                          <a:solidFill>
-                            <a:srgbClr val="3B82F6"/>
-                          </a:solidFill>
-                          <a:latin typeface="Cambria Math" panose="02040503050406030204" pitchFamily="18" charset="0"/>
-                        </a:rPr>
-                        <m:t> </m:t>
-                      </m:r>
-                      <m:sSub>
-                        <m:sSubPr>
-                          <m:ctrlPr>
-                            <a:rPr lang="en-GB" sz="1050" b="1" i="1" dirty="0" err="1">
-                              <a:solidFill>
-                                <a:srgbClr val="3B82F6"/>
-                              </a:solidFill>
-                              <a:latin typeface="Cambria Math" panose="02040503050406030204" pitchFamily="18" charset="0"/>
-                            </a:rPr>
-                          </m:ctrlPr>
-                        </m:sSubPr>
-                        <m:e>
-                          <m:r>
-                            <a:rPr lang="en-GB" sz="1050" b="1" i="1" dirty="0" err="1">
-                              <a:solidFill>
-                                <a:srgbClr val="3B82F6"/>
-                              </a:solidFill>
-                              <a:latin typeface="Cambria Math" panose="02040503050406030204" pitchFamily="18" charset="0"/>
-                            </a:rPr>
-                            <m:t>𝑽</m:t>
-                          </m:r>
-                        </m:e>
-                        <m:sub>
-                          <m:r>
-                            <a:rPr lang="en-GB" sz="1050" b="1" i="1" dirty="0" err="1">
-                              <a:solidFill>
-                                <a:srgbClr val="3B82F6"/>
-                              </a:solidFill>
-                              <a:latin typeface="Cambria Math" panose="02040503050406030204" pitchFamily="18" charset="0"/>
-                            </a:rPr>
-                            <m:t>𝒊𝒋</m:t>
-                          </m:r>
-                        </m:sub>
-                      </m:sSub>
-                      <m:r>
-                        <a:rPr lang="en-GB" sz="1050" b="1" i="1" dirty="0">
-                          <a:solidFill>
-                            <a:srgbClr val="3B82F6"/>
-                          </a:solidFill>
-                          <a:latin typeface="Cambria Math" panose="02040503050406030204" pitchFamily="18" charset="0"/>
-                        </a:rPr>
-                        <m:t>≤ </m:t>
-                      </m:r>
-                      <m:r>
-                        <a:rPr lang="en-GB" sz="1050" b="1" i="1" dirty="0">
-                          <a:solidFill>
-                            <a:srgbClr val="3B82F6"/>
-                          </a:solidFill>
-                          <a:latin typeface="Cambria Math" panose="02040503050406030204" pitchFamily="18" charset="0"/>
-                        </a:rPr>
-                        <m:t>𝟏</m:t>
-                      </m:r>
-                      <m:r>
-                        <a:rPr lang="en-GB" sz="1050" b="1" i="1" dirty="0">
-                          <a:solidFill>
-                            <a:srgbClr val="3B82F6"/>
-                          </a:solidFill>
-                          <a:latin typeface="Cambria Math" panose="02040503050406030204" pitchFamily="18" charset="0"/>
-                        </a:rPr>
-                        <m:t>   ∀</m:t>
-                      </m:r>
-                      <m:r>
-                        <a:rPr lang="en-GB" sz="1050" b="1" i="1" dirty="0" err="1">
-                          <a:solidFill>
-                            <a:srgbClr val="3B82F6"/>
-                          </a:solidFill>
-                          <a:latin typeface="Cambria Math" panose="02040503050406030204" pitchFamily="18" charset="0"/>
-                        </a:rPr>
-                        <m:t>𝒊</m:t>
-                      </m:r>
-                    </m:oMath>
-                  </m:oMathPara>
                   <m:oMathPara xmlns:m="http://schemas.openxmlformats.org/officeDocument/2006/math">
                     <m:oMathParaPr>
                       <m:jc m:val="centerGroup"/>
@@ -26538,14 +27239,103 @@
                         </a:rPr>
                         <m:t>𝒋</m:t>
                       </m:r>
+                      <m:r>
+                        <a:rPr lang="en-GB" sz="1050" b="1" i="0" dirty="0" smtClean="0">
+                          <a:solidFill>
+                            <a:srgbClr val="3B82F6"/>
+                          </a:solidFill>
+                          <a:latin typeface="Cambria Math" panose="02040503050406030204" pitchFamily="18" charset="0"/>
+                        </a:rPr>
+                        <m:t>𝚺</m:t>
+                      </m:r>
+                      <m:r>
+                        <a:rPr lang="en-GB" sz="1050" b="1" i="1" dirty="0">
+                          <a:solidFill>
+                            <a:srgbClr val="3B82F6"/>
+                          </a:solidFill>
+                          <a:latin typeface="Cambria Math" panose="02040503050406030204" pitchFamily="18" charset="0"/>
+                        </a:rPr>
+                        <m:t> </m:t>
+                      </m:r>
+                      <m:sSub>
+                        <m:sSubPr>
+                          <m:ctrlPr>
+                            <a:rPr lang="en-GB" sz="1050" b="1" i="1" dirty="0" err="1">
+                              <a:solidFill>
+                                <a:srgbClr val="3B82F6"/>
+                              </a:solidFill>
+                              <a:latin typeface="Cambria Math" panose="02040503050406030204" pitchFamily="18" charset="0"/>
+                            </a:rPr>
+                          </m:ctrlPr>
+                        </m:sSubPr>
+                        <m:e>
+                          <m:r>
+                            <a:rPr lang="en-GB" sz="1050" b="1" i="1" dirty="0" err="1">
+                              <a:solidFill>
+                                <a:srgbClr val="3B82F6"/>
+                              </a:solidFill>
+                              <a:latin typeface="Cambria Math" panose="02040503050406030204" pitchFamily="18" charset="0"/>
+                            </a:rPr>
+                            <m:t>𝑽</m:t>
+                          </m:r>
+                        </m:e>
+                        <m:sub>
+                          <m:r>
+                            <a:rPr lang="en-GB" sz="1050" b="1" i="1" dirty="0" err="1">
+                              <a:solidFill>
+                                <a:srgbClr val="3B82F6"/>
+                              </a:solidFill>
+                              <a:latin typeface="Cambria Math" panose="02040503050406030204" pitchFamily="18" charset="0"/>
+                            </a:rPr>
+                            <m:t>𝒊𝒋</m:t>
+                          </m:r>
+                        </m:sub>
+                      </m:sSub>
+                      <m:r>
+                        <a:rPr lang="en-GB" sz="1050" b="1" i="1" dirty="0">
+                          <a:solidFill>
+                            <a:srgbClr val="3B82F6"/>
+                          </a:solidFill>
+                          <a:latin typeface="Cambria Math" panose="02040503050406030204" pitchFamily="18" charset="0"/>
+                        </a:rPr>
+                        <m:t>≤ </m:t>
+                      </m:r>
+                      <m:r>
+                        <a:rPr lang="en-GB" sz="1050" b="1" i="1" dirty="0">
+                          <a:solidFill>
+                            <a:srgbClr val="3B82F6"/>
+                          </a:solidFill>
+                          <a:latin typeface="Cambria Math" panose="02040503050406030204" pitchFamily="18" charset="0"/>
+                        </a:rPr>
+                        <m:t>𝟏</m:t>
+                      </m:r>
+                      <m:r>
+                        <a:rPr lang="en-GB" sz="1050" b="1" i="1" dirty="0">
+                          <a:solidFill>
+                            <a:srgbClr val="3B82F6"/>
+                          </a:solidFill>
+                          <a:latin typeface="Cambria Math" panose="02040503050406030204" pitchFamily="18" charset="0"/>
+                        </a:rPr>
+                        <m:t>   ∀</m:t>
+                      </m:r>
+                      <m:r>
+                        <a:rPr lang="en-GB" sz="1050" b="1" i="1" dirty="0" err="1">
+                          <a:solidFill>
+                            <a:srgbClr val="3B82F6"/>
+                          </a:solidFill>
+                          <a:latin typeface="Cambria Math" panose="02040503050406030204" pitchFamily="18" charset="0"/>
+                        </a:rPr>
+                        <m:t>𝒊</m:t>
+                      </m:r>
                     </m:oMath>
                   </m:oMathPara>
                 </a14:m>
+                <a:endParaRPr/>
               </a:p>
             </p:txBody>
           </p:sp>
         </mc:Choice>
-        <mc:Fallback>
+        <mc:Fallback xmlns="">
           <p:sp>
             <p:nvSpPr>
               <p:cNvPr id="11" name="TextBox 10"/>
@@ -26790,8 +27580,8 @@
           </a:p>
         </p:txBody>
       </p:sp>
-      <mc:AlternateContent xmlns:mc="http://schemas.openxmlformats.org/markup-compatibility/2006">
-        <mc:Choice xmlns:a14="http://schemas.microsoft.com/office/drawing/2010/main" Requires="a14">
+      <mc:AlternateContent xmlns:mc="http://schemas.openxmlformats.org/markup-compatibility/2006" xmlns:a14="http://schemas.microsoft.com/office/drawing/2010/main">
+        <mc:Choice Requires="a14">
           <p:sp>
             <p:nvSpPr>
               <p:cNvPr id="17" name="TextBox 16"/>
@@ -27260,7 +28050,7 @@
             </p:txBody>
           </p:sp>
         </mc:Choice>
-        <mc:Fallback>
+        <mc:Fallback xmlns="">
           <p:sp>
             <p:nvSpPr>
               <p:cNvPr id="17" name="TextBox 16"/>
@@ -27299,8 +28089,8 @@
           </p:sp>
         </mc:Fallback>
       </mc:AlternateContent>
-      <mc:AlternateContent xmlns:mc="http://schemas.openxmlformats.org/markup-compatibility/2006">
-        <mc:Choice xmlns:a14="http://schemas.microsoft.com/office/drawing/2010/main" Requires="a14">
+      <mc:AlternateContent xmlns:mc="http://schemas.openxmlformats.org/markup-compatibility/2006" xmlns:a14="http://schemas.microsoft.com/office/drawing/2010/main">
+        <mc:Choice Requires="a14">
           <p:sp>
             <p:nvSpPr>
               <p:cNvPr id="18" name="TextBox 17"/>
@@ -27325,496 +28115,6 @@
               <a:p>
                 <a:pPr algn="l"/>
                 <a14:m>
-                  <m:oMathPara xmlns:m="http://schemas.openxmlformats.org/officeDocument/2006/math">
-                    <m:oMathParaPr>
-                      <m:jc m:val="centerGroup"/>
-                    </m:oMathParaPr>
-                    <m:oMath xmlns:m="http://schemas.openxmlformats.org/officeDocument/2006/math">
-                      <m:sSub>
-                        <m:sSubPr>
-                          <m:ctrlPr>
-                            <a:rPr lang="en-GB" sz="1050" b="1" i="1" dirty="0" smtClean="0">
-                              <a:solidFill>
-                                <a:srgbClr val="14B8A6"/>
-                              </a:solidFill>
-                              <a:latin typeface="Cambria Math" panose="02040503050406030204" pitchFamily="18" charset="0"/>
-                            </a:rPr>
-                          </m:ctrlPr>
-                        </m:sSubPr>
-                        <m:e>
-                          <m:r>
-                            <a:rPr lang="en-GB" sz="1050" b="1" i="1" dirty="0" smtClean="0">
-                              <a:solidFill>
-                                <a:srgbClr val="14B8A6"/>
-                              </a:solidFill>
-                              <a:latin typeface="Cambria Math" panose="02040503050406030204" pitchFamily="18" charset="0"/>
-                            </a:rPr>
-                            <m:t>𝒙</m:t>
-                          </m:r>
-                        </m:e>
-                        <m:sub>
-                          <m:r>
-                            <a:rPr lang="en-GB" sz="1050" b="1" i="1" dirty="0" smtClean="0">
-                              <a:solidFill>
-                                <a:srgbClr val="14B8A6"/>
-                              </a:solidFill>
-                              <a:latin typeface="Cambria Math" panose="02040503050406030204" pitchFamily="18" charset="0"/>
-                            </a:rPr>
-                            <m:t>𝒊</m:t>
-                          </m:r>
-                        </m:sub>
-                      </m:sSub>
-                      <m:r>
-                        <a:rPr lang="en-GB" sz="1050" b="1" i="1" dirty="0">
-                          <a:solidFill>
-                            <a:srgbClr val="14B8A6"/>
-                          </a:solidFill>
-                          <a:latin typeface="Cambria Math" panose="02040503050406030204" pitchFamily="18" charset="0"/>
-                        </a:rPr>
-                        <m:t>+ </m:t>
-                      </m:r>
-                      <m:r>
-                        <a:rPr lang="en-GB" sz="1050" b="1" i="1" dirty="0" err="1">
-                          <a:solidFill>
-                            <a:srgbClr val="14B8A6"/>
-                          </a:solidFill>
-                          <a:latin typeface="Cambria Math" panose="02040503050406030204" pitchFamily="18" charset="0"/>
-                        </a:rPr>
-                        <m:t>𝒅</m:t>
-                      </m:r>
-                      <m:sSub>
-                        <m:sSubPr>
-                          <m:ctrlPr>
-                            <a:rPr lang="en-GB" sz="1050" b="1" i="1" dirty="0" err="1">
-                              <a:solidFill>
-                                <a:srgbClr val="14B8A6"/>
-                              </a:solidFill>
-                              <a:latin typeface="Cambria Math" panose="02040503050406030204" pitchFamily="18" charset="0"/>
-                            </a:rPr>
-                          </m:ctrlPr>
-                        </m:sSubPr>
-                        <m:e>
-                          <m:r>
-                            <a:rPr lang="en-GB" sz="1050" b="1" i="1" dirty="0" err="1">
-                              <a:solidFill>
-                                <a:srgbClr val="14B8A6"/>
-                              </a:solidFill>
-                              <a:latin typeface="Cambria Math" panose="02040503050406030204" pitchFamily="18" charset="0"/>
-                            </a:rPr>
-                            <m:t>𝒙</m:t>
-                          </m:r>
-                        </m:e>
-                        <m:sub>
-                          <m:r>
-                            <a:rPr lang="en-GB" sz="1050" b="1" i="1" dirty="0" err="1">
-                              <a:solidFill>
-                                <a:srgbClr val="14B8A6"/>
-                              </a:solidFill>
-                              <a:latin typeface="Cambria Math" panose="02040503050406030204" pitchFamily="18" charset="0"/>
-                            </a:rPr>
-                            <m:t>𝒊</m:t>
-                          </m:r>
-                        </m:sub>
-                      </m:sSub>
-                      <m:r>
-                        <a:rPr lang="en-GB" sz="1050" b="1" i="1" dirty="0">
-                          <a:solidFill>
-                            <a:srgbClr val="14B8A6"/>
-                          </a:solidFill>
-                          <a:latin typeface="Cambria Math" panose="02040503050406030204" pitchFamily="18" charset="0"/>
-                        </a:rPr>
-                        <m:t>≤ </m:t>
-                      </m:r>
-                      <m:sSub>
-                        <m:sSubPr>
-                          <m:ctrlPr>
-                            <a:rPr lang="en-GB" sz="1050" b="1" i="1" dirty="0" err="1">
-                              <a:solidFill>
-                                <a:srgbClr val="14B8A6"/>
-                              </a:solidFill>
-                              <a:latin typeface="Cambria Math" panose="02040503050406030204" pitchFamily="18" charset="0"/>
-                            </a:rPr>
-                          </m:ctrlPr>
-                        </m:sSubPr>
-                        <m:e>
-                          <m:r>
-                            <a:rPr lang="en-GB" sz="1050" b="1" i="1" dirty="0" err="1">
-                              <a:solidFill>
-                                <a:srgbClr val="14B8A6"/>
-                              </a:solidFill>
-                              <a:latin typeface="Cambria Math" panose="02040503050406030204" pitchFamily="18" charset="0"/>
-                            </a:rPr>
-                            <m:t>𝑳</m:t>
-                          </m:r>
-                        </m:e>
-                        <m:sub>
-                          <m:sSub>
-                            <m:sSubPr>
-                              <m:ctrlPr>
-                                <a:rPr lang="en-GB" sz="1050" b="1" i="1" dirty="0" err="1">
-                                  <a:solidFill>
-                                    <a:srgbClr val="14B8A6"/>
-                                  </a:solidFill>
-                                  <a:latin typeface="Cambria Math" panose="02040503050406030204" pitchFamily="18" charset="0"/>
-                                </a:rPr>
-                              </m:ctrlPr>
-                            </m:sSubPr>
-                            <m:e>
-                              <m:r>
-                                <a:rPr lang="en-GB" sz="1050" b="1" i="1" dirty="0" err="1">
-                                  <a:solidFill>
-                                    <a:srgbClr val="14B8A6"/>
-                                  </a:solidFill>
-                                  <a:latin typeface="Cambria Math" panose="02040503050406030204" pitchFamily="18" charset="0"/>
-                                </a:rPr>
-                                <m:t>𝑿</m:t>
-                              </m:r>
-                            </m:e>
-                            <m:sub>
-                              <m:r>
-                                <a:rPr lang="en-GB" sz="1050" b="1" i="1" dirty="0" err="1">
-                                  <a:solidFill>
-                                    <a:srgbClr val="14B8A6"/>
-                                  </a:solidFill>
-                                  <a:latin typeface="Cambria Math" panose="02040503050406030204" pitchFamily="18" charset="0"/>
-                                </a:rPr>
-                                <m:t>𝒋</m:t>
-                              </m:r>
-                            </m:sub>
-                          </m:sSub>
-                        </m:sub>
-                      </m:sSub>
-                      <m:r>
-                        <a:rPr lang="en-GB" sz="1050" b="1" i="1" dirty="0">
-                          <a:solidFill>
-                            <a:srgbClr val="14B8A6"/>
-                          </a:solidFill>
-                          <a:latin typeface="Cambria Math" panose="02040503050406030204" pitchFamily="18" charset="0"/>
-                        </a:rPr>
-                        <m:t>+ </m:t>
-                      </m:r>
-                      <m:r>
-                        <a:rPr lang="en-GB" sz="1050" b="1" i="1" dirty="0">
-                          <a:solidFill>
-                            <a:srgbClr val="14B8A6"/>
-                          </a:solidFill>
-                          <a:latin typeface="Cambria Math" panose="02040503050406030204" pitchFamily="18" charset="0"/>
-                        </a:rPr>
-                        <m:t>𝑴</m:t>
-                      </m:r>
-                      <m:d>
-                        <m:dPr>
-                          <m:ctrlPr>
-                            <a:rPr lang="en-GB" sz="1050" b="1" i="1" dirty="0">
-                              <a:solidFill>
-                                <a:srgbClr val="14B8A6"/>
-                              </a:solidFill>
-                              <a:latin typeface="Cambria Math" panose="02040503050406030204" pitchFamily="18" charset="0"/>
-                            </a:rPr>
-                          </m:ctrlPr>
-                        </m:dPr>
-                        <m:e>
-                          <m:r>
-                            <a:rPr lang="en-GB" sz="1050" b="1" i="1" dirty="0">
-                              <a:solidFill>
-                                <a:srgbClr val="14B8A6"/>
-                              </a:solidFill>
-                              <a:latin typeface="Cambria Math" panose="02040503050406030204" pitchFamily="18" charset="0"/>
-                            </a:rPr>
-                            <m:t>𝟏</m:t>
-                          </m:r>
-                          <m:r>
-                            <a:rPr lang="en-GB" sz="1050" b="1" i="1" dirty="0">
-                              <a:solidFill>
-                                <a:srgbClr val="14B8A6"/>
-                              </a:solidFill>
-                              <a:latin typeface="Cambria Math" panose="02040503050406030204" pitchFamily="18" charset="0"/>
-                            </a:rPr>
-                            <m:t>−</m:t>
-                          </m:r>
-                          <m:sSub>
-                            <m:sSubPr>
-                              <m:ctrlPr>
-                                <a:rPr lang="en-GB" sz="1050" b="1" i="1" dirty="0">
-                                  <a:solidFill>
-                                    <a:srgbClr val="14B8A6"/>
-                                  </a:solidFill>
-                                  <a:latin typeface="Cambria Math" panose="02040503050406030204" pitchFamily="18" charset="0"/>
-                                </a:rPr>
-                              </m:ctrlPr>
-                            </m:sSubPr>
-                            <m:e>
-                              <m:r>
-                                <a:rPr lang="en-GB" sz="1050" b="1" i="1" dirty="0">
-                                  <a:solidFill>
-                                    <a:srgbClr val="14B8A6"/>
-                                  </a:solidFill>
-                                  <a:latin typeface="Cambria Math" panose="02040503050406030204" pitchFamily="18" charset="0"/>
-                                </a:rPr>
-                                <m:t>𝑽</m:t>
-                              </m:r>
-                            </m:e>
-                            <m:sub>
-                              <m:r>
-                                <a:rPr lang="en-GB" sz="1050" b="1" i="1" dirty="0">
-                                  <a:solidFill>
-                                    <a:srgbClr val="14B8A6"/>
-                                  </a:solidFill>
-                                  <a:latin typeface="Cambria Math" panose="02040503050406030204" pitchFamily="18" charset="0"/>
-                                </a:rPr>
-                                <m:t>𝒊𝒋</m:t>
-                              </m:r>
-                            </m:sub>
-                          </m:sSub>
-                        </m:e>
-                      </m:d>
-                    </m:oMath>
-                  </m:oMathPara>
-                  <m:oMathPara xmlns:m="http://schemas.openxmlformats.org/officeDocument/2006/math">
-                    <m:oMathParaPr>
-                      <m:jc m:val="centerGroup"/>
-                    </m:oMathParaPr>
-                    <m:oMath xmlns:m="http://schemas.openxmlformats.org/officeDocument/2006/math">
-                      <m:sSub>
-                        <m:sSubPr>
-                          <m:ctrlPr>
-                            <a:rPr lang="en-GB" sz="1050" b="1" i="1" dirty="0" err="1">
-                              <a:solidFill>
-                                <a:srgbClr val="14B8A6"/>
-                              </a:solidFill>
-                              <a:latin typeface="Cambria Math" panose="02040503050406030204" pitchFamily="18" charset="0"/>
-                            </a:rPr>
-                          </m:ctrlPr>
-                        </m:sSubPr>
-                        <m:e>
-                          <m:r>
-                            <a:rPr lang="en-GB" sz="1050" b="1" i="1" dirty="0" err="1">
-                              <a:solidFill>
-                                <a:srgbClr val="14B8A6"/>
-                              </a:solidFill>
-                              <a:latin typeface="Cambria Math" panose="02040503050406030204" pitchFamily="18" charset="0"/>
-                            </a:rPr>
-                            <m:t>𝒚</m:t>
-                          </m:r>
-                        </m:e>
-                        <m:sub>
-                          <m:r>
-                            <a:rPr lang="en-GB" sz="1050" b="1" i="1" dirty="0" err="1">
-                              <a:solidFill>
-                                <a:srgbClr val="14B8A6"/>
-                              </a:solidFill>
-                              <a:latin typeface="Cambria Math" panose="02040503050406030204" pitchFamily="18" charset="0"/>
-                            </a:rPr>
-                            <m:t>𝒊</m:t>
-                          </m:r>
-                        </m:sub>
-                      </m:sSub>
-                      <m:r>
-                        <a:rPr lang="en-GB" sz="1050" b="1" i="1" dirty="0">
-                          <a:solidFill>
-                            <a:srgbClr val="14B8A6"/>
-                          </a:solidFill>
-                          <a:latin typeface="Cambria Math" panose="02040503050406030204" pitchFamily="18" charset="0"/>
-                        </a:rPr>
-                        <m:t>+ </m:t>
-                      </m:r>
-                      <m:r>
-                        <a:rPr lang="en-GB" sz="1050" b="1" i="1" dirty="0" err="1">
-                          <a:solidFill>
-                            <a:srgbClr val="14B8A6"/>
-                          </a:solidFill>
-                          <a:latin typeface="Cambria Math" panose="02040503050406030204" pitchFamily="18" charset="0"/>
-                        </a:rPr>
-                        <m:t>𝒅</m:t>
-                      </m:r>
-                      <m:sSub>
-                        <m:sSubPr>
-                          <m:ctrlPr>
-                            <a:rPr lang="en-GB" sz="1050" b="1" i="1" dirty="0" err="1">
-                              <a:solidFill>
-                                <a:srgbClr val="14B8A6"/>
-                              </a:solidFill>
-                              <a:latin typeface="Cambria Math" panose="02040503050406030204" pitchFamily="18" charset="0"/>
-                            </a:rPr>
-                          </m:ctrlPr>
-                        </m:sSubPr>
-                        <m:e>
-                          <m:r>
-                            <a:rPr lang="en-GB" sz="1050" b="1" i="1" dirty="0" err="1">
-                              <a:solidFill>
-                                <a:srgbClr val="14B8A6"/>
-                              </a:solidFill>
-                              <a:latin typeface="Cambria Math" panose="02040503050406030204" pitchFamily="18" charset="0"/>
-                            </a:rPr>
-                            <m:t>𝒚</m:t>
-                          </m:r>
-                        </m:e>
-                        <m:sub>
-                          <m:r>
-                            <a:rPr lang="en-GB" sz="1050" b="1" i="1" dirty="0" err="1">
-                              <a:solidFill>
-                                <a:srgbClr val="14B8A6"/>
-                              </a:solidFill>
-                              <a:latin typeface="Cambria Math" panose="02040503050406030204" pitchFamily="18" charset="0"/>
-                            </a:rPr>
-                            <m:t>𝒊</m:t>
-                          </m:r>
-                        </m:sub>
-                      </m:sSub>
-                      <m:r>
-                        <a:rPr lang="en-GB" sz="1050" b="1" i="1" dirty="0">
-                          <a:solidFill>
-                            <a:srgbClr val="14B8A6"/>
-                          </a:solidFill>
-                          <a:latin typeface="Cambria Math" panose="02040503050406030204" pitchFamily="18" charset="0"/>
-                        </a:rPr>
-                        <m:t>≤ </m:t>
-                      </m:r>
-                      <m:sSub>
-                        <m:sSubPr>
-                          <m:ctrlPr>
-                            <a:rPr lang="en-GB" sz="1050" b="1" i="1" dirty="0" err="1">
-                              <a:solidFill>
-                                <a:srgbClr val="14B8A6"/>
-                              </a:solidFill>
-                              <a:latin typeface="Cambria Math" panose="02040503050406030204" pitchFamily="18" charset="0"/>
-                            </a:rPr>
-                          </m:ctrlPr>
-                        </m:sSubPr>
-                        <m:e>
-                          <m:r>
-                            <a:rPr lang="en-GB" sz="1050" b="1" i="1" dirty="0" err="1">
-                              <a:solidFill>
-                                <a:srgbClr val="14B8A6"/>
-                              </a:solidFill>
-                              <a:latin typeface="Cambria Math" panose="02040503050406030204" pitchFamily="18" charset="0"/>
-                            </a:rPr>
-                            <m:t>𝑳</m:t>
-                          </m:r>
-                        </m:e>
-                        <m:sub>
-                          <m:sSub>
-                            <m:sSubPr>
-                              <m:ctrlPr>
-                                <a:rPr lang="en-GB" sz="1050" b="1" i="1" dirty="0" err="1">
-                                  <a:solidFill>
-                                    <a:srgbClr val="14B8A6"/>
-                                  </a:solidFill>
-                                  <a:latin typeface="Cambria Math" panose="02040503050406030204" pitchFamily="18" charset="0"/>
-                                </a:rPr>
-                              </m:ctrlPr>
-                            </m:sSubPr>
-                            <m:e>
-                              <m:r>
-                                <a:rPr lang="en-GB" sz="1050" b="1" i="1" dirty="0" err="1">
-                                  <a:solidFill>
-                                    <a:srgbClr val="14B8A6"/>
-                                  </a:solidFill>
-                                  <a:latin typeface="Cambria Math" panose="02040503050406030204" pitchFamily="18" charset="0"/>
-                                </a:rPr>
-                                <m:t>𝒀</m:t>
-                              </m:r>
-                            </m:e>
-                            <m:sub>
-                              <m:r>
-                                <a:rPr lang="en-GB" sz="1050" b="1" i="1" dirty="0" err="1">
-                                  <a:solidFill>
-                                    <a:srgbClr val="14B8A6"/>
-                                  </a:solidFill>
-                                  <a:latin typeface="Cambria Math" panose="02040503050406030204" pitchFamily="18" charset="0"/>
-                                </a:rPr>
-                                <m:t>𝒋</m:t>
-                              </m:r>
-                            </m:sub>
-                          </m:sSub>
-                        </m:sub>
-                      </m:sSub>
-                      <m:r>
-                        <a:rPr lang="en-GB" sz="1050" b="1" i="1" dirty="0">
-                          <a:solidFill>
-                            <a:srgbClr val="14B8A6"/>
-                          </a:solidFill>
-                          <a:latin typeface="Cambria Math" panose="02040503050406030204" pitchFamily="18" charset="0"/>
-                        </a:rPr>
-                        <m:t>+ </m:t>
-                      </m:r>
-                      <m:r>
-                        <a:rPr lang="en-GB" sz="1050" b="1" i="1" dirty="0">
-                          <a:solidFill>
-                            <a:srgbClr val="14B8A6"/>
-                          </a:solidFill>
-                          <a:latin typeface="Cambria Math" panose="02040503050406030204" pitchFamily="18" charset="0"/>
-                        </a:rPr>
-                        <m:t>𝑴</m:t>
-                      </m:r>
-                      <m:d>
-                        <m:dPr>
-                          <m:ctrlPr>
-                            <a:rPr lang="en-GB" sz="1050" b="1" i="1" dirty="0">
-                              <a:solidFill>
-                                <a:srgbClr val="14B8A6"/>
-                              </a:solidFill>
-                              <a:latin typeface="Cambria Math" panose="02040503050406030204" pitchFamily="18" charset="0"/>
-                            </a:rPr>
-                          </m:ctrlPr>
-                        </m:dPr>
-                        <m:e>
-                          <m:r>
-                            <a:rPr lang="en-GB" sz="1050" b="1" i="1" dirty="0">
-                              <a:solidFill>
-                                <a:srgbClr val="14B8A6"/>
-                              </a:solidFill>
-                              <a:latin typeface="Cambria Math" panose="02040503050406030204" pitchFamily="18" charset="0"/>
-                            </a:rPr>
-                            <m:t>𝟏</m:t>
-                          </m:r>
-                          <m:r>
-                            <a:rPr lang="en-GB" sz="1050" b="1" i="1" dirty="0">
-                              <a:solidFill>
-                                <a:srgbClr val="14B8A6"/>
-                              </a:solidFill>
-                              <a:latin typeface="Cambria Math" panose="02040503050406030204" pitchFamily="18" charset="0"/>
-                            </a:rPr>
-                            <m:t>−</m:t>
-                          </m:r>
-                          <m:sSub>
-                            <m:sSubPr>
-                              <m:ctrlPr>
-                                <a:rPr lang="en-GB" sz="1050" b="1" i="1" dirty="0">
-                                  <a:solidFill>
-                                    <a:srgbClr val="14B8A6"/>
-                                  </a:solidFill>
-                                  <a:latin typeface="Cambria Math" panose="02040503050406030204" pitchFamily="18" charset="0"/>
-                                </a:rPr>
-                              </m:ctrlPr>
-                            </m:sSubPr>
-                            <m:e>
-                              <m:r>
-                                <a:rPr lang="en-GB" sz="1050" b="1" i="1" dirty="0">
-                                  <a:solidFill>
-                                    <a:srgbClr val="14B8A6"/>
-                                  </a:solidFill>
-                                  <a:latin typeface="Cambria Math" panose="02040503050406030204" pitchFamily="18" charset="0"/>
-                                </a:rPr>
-                                <m:t>𝑽</m:t>
-                              </m:r>
-                            </m:e>
-                            <m:sub>
-                              <m:r>
-                                <a:rPr lang="en-GB" sz="1050" b="1" i="1" dirty="0">
-                                  <a:solidFill>
-                                    <a:srgbClr val="14B8A6"/>
-                                  </a:solidFill>
-                                  <a:latin typeface="Cambria Math" panose="02040503050406030204" pitchFamily="18" charset="0"/>
-                                </a:rPr>
-                                <m:t>𝒊𝒋</m:t>
-                              </m:r>
-                            </m:sub>
-                          </m:sSub>
-                        </m:e>
-                      </m:d>
-                    </m:oMath>
-                  </m:oMathPara>
                   <m:oMathPara xmlns:m="http://schemas.openxmlformats.org/officeDocument/2006/math">
                     <m:oMathParaPr>
                       <m:jc m:val="centerGroup"/>
@@ -28058,14 +28358,491 @@
                           </m:sSub>
                         </m:e>
                       </m:d>
+                      <m:sSub>
+                        <m:sSubPr>
+                          <m:ctrlPr>
+                            <a:rPr lang="en-GB" sz="1050" b="1" i="1" dirty="0" err="1">
+                              <a:solidFill>
+                                <a:srgbClr val="14B8A6"/>
+                              </a:solidFill>
+                              <a:latin typeface="Cambria Math" panose="02040503050406030204" pitchFamily="18" charset="0"/>
+                            </a:rPr>
+                          </m:ctrlPr>
+                        </m:sSubPr>
+                        <m:e>
+                          <m:r>
+                            <a:rPr lang="en-GB" sz="1050" b="1" i="1" dirty="0" err="1">
+                              <a:solidFill>
+                                <a:srgbClr val="14B8A6"/>
+                              </a:solidFill>
+                              <a:latin typeface="Cambria Math" panose="02040503050406030204" pitchFamily="18" charset="0"/>
+                            </a:rPr>
+                            <m:t>𝒚</m:t>
+                          </m:r>
+                        </m:e>
+                        <m:sub>
+                          <m:r>
+                            <a:rPr lang="en-GB" sz="1050" b="1" i="1" dirty="0" err="1">
+                              <a:solidFill>
+                                <a:srgbClr val="14B8A6"/>
+                              </a:solidFill>
+                              <a:latin typeface="Cambria Math" panose="02040503050406030204" pitchFamily="18" charset="0"/>
+                            </a:rPr>
+                            <m:t>𝒊</m:t>
+                          </m:r>
+                        </m:sub>
+                      </m:sSub>
+                      <m:r>
+                        <a:rPr lang="en-GB" sz="1050" b="1" i="1" dirty="0">
+                          <a:solidFill>
+                            <a:srgbClr val="14B8A6"/>
+                          </a:solidFill>
+                          <a:latin typeface="Cambria Math" panose="02040503050406030204" pitchFamily="18" charset="0"/>
+                        </a:rPr>
+                        <m:t>+ </m:t>
+                      </m:r>
+                      <m:r>
+                        <a:rPr lang="en-GB" sz="1050" b="1" i="1" dirty="0" err="1">
+                          <a:solidFill>
+                            <a:srgbClr val="14B8A6"/>
+                          </a:solidFill>
+                          <a:latin typeface="Cambria Math" panose="02040503050406030204" pitchFamily="18" charset="0"/>
+                        </a:rPr>
+                        <m:t>𝒅</m:t>
+                      </m:r>
+                      <m:sSub>
+                        <m:sSubPr>
+                          <m:ctrlPr>
+                            <a:rPr lang="en-GB" sz="1050" b="1" i="1" dirty="0" err="1">
+                              <a:solidFill>
+                                <a:srgbClr val="14B8A6"/>
+                              </a:solidFill>
+                              <a:latin typeface="Cambria Math" panose="02040503050406030204" pitchFamily="18" charset="0"/>
+                            </a:rPr>
+                          </m:ctrlPr>
+                        </m:sSubPr>
+                        <m:e>
+                          <m:r>
+                            <a:rPr lang="en-GB" sz="1050" b="1" i="1" dirty="0" err="1">
+                              <a:solidFill>
+                                <a:srgbClr val="14B8A6"/>
+                              </a:solidFill>
+                              <a:latin typeface="Cambria Math" panose="02040503050406030204" pitchFamily="18" charset="0"/>
+                            </a:rPr>
+                            <m:t>𝒚</m:t>
+                          </m:r>
+                        </m:e>
+                        <m:sub>
+                          <m:r>
+                            <a:rPr lang="en-GB" sz="1050" b="1" i="1" dirty="0" err="1">
+                              <a:solidFill>
+                                <a:srgbClr val="14B8A6"/>
+                              </a:solidFill>
+                              <a:latin typeface="Cambria Math" panose="02040503050406030204" pitchFamily="18" charset="0"/>
+                            </a:rPr>
+                            <m:t>𝒊</m:t>
+                          </m:r>
+                        </m:sub>
+                      </m:sSub>
+                      <m:r>
+                        <a:rPr lang="en-GB" sz="1050" b="1" i="1" dirty="0">
+                          <a:solidFill>
+                            <a:srgbClr val="14B8A6"/>
+                          </a:solidFill>
+                          <a:latin typeface="Cambria Math" panose="02040503050406030204" pitchFamily="18" charset="0"/>
+                        </a:rPr>
+                        <m:t>≤ </m:t>
+                      </m:r>
+                      <m:sSub>
+                        <m:sSubPr>
+                          <m:ctrlPr>
+                            <a:rPr lang="en-GB" sz="1050" b="1" i="1" dirty="0" err="1">
+                              <a:solidFill>
+                                <a:srgbClr val="14B8A6"/>
+                              </a:solidFill>
+                              <a:latin typeface="Cambria Math" panose="02040503050406030204" pitchFamily="18" charset="0"/>
+                            </a:rPr>
+                          </m:ctrlPr>
+                        </m:sSubPr>
+                        <m:e>
+                          <m:r>
+                            <a:rPr lang="en-GB" sz="1050" b="1" i="1" dirty="0" err="1">
+                              <a:solidFill>
+                                <a:srgbClr val="14B8A6"/>
+                              </a:solidFill>
+                              <a:latin typeface="Cambria Math" panose="02040503050406030204" pitchFamily="18" charset="0"/>
+                            </a:rPr>
+                            <m:t>𝑳</m:t>
+                          </m:r>
+                        </m:e>
+                        <m:sub>
+                          <m:sSub>
+                            <m:sSubPr>
+                              <m:ctrlPr>
+                                <a:rPr lang="en-GB" sz="1050" b="1" i="1" dirty="0" err="1">
+                                  <a:solidFill>
+                                    <a:srgbClr val="14B8A6"/>
+                                  </a:solidFill>
+                                  <a:latin typeface="Cambria Math" panose="02040503050406030204" pitchFamily="18" charset="0"/>
+                                </a:rPr>
+                              </m:ctrlPr>
+                            </m:sSubPr>
+                            <m:e>
+                              <m:r>
+                                <a:rPr lang="en-GB" sz="1050" b="1" i="1" dirty="0" err="1">
+                                  <a:solidFill>
+                                    <a:srgbClr val="14B8A6"/>
+                                  </a:solidFill>
+                                  <a:latin typeface="Cambria Math" panose="02040503050406030204" pitchFamily="18" charset="0"/>
+                                </a:rPr>
+                                <m:t>𝒀</m:t>
+                              </m:r>
+                            </m:e>
+                            <m:sub>
+                              <m:r>
+                                <a:rPr lang="en-GB" sz="1050" b="1" i="1" dirty="0" err="1">
+                                  <a:solidFill>
+                                    <a:srgbClr val="14B8A6"/>
+                                  </a:solidFill>
+                                  <a:latin typeface="Cambria Math" panose="02040503050406030204" pitchFamily="18" charset="0"/>
+                                </a:rPr>
+                                <m:t>𝒋</m:t>
+                              </m:r>
+                            </m:sub>
+                          </m:sSub>
+                        </m:sub>
+                      </m:sSub>
+                      <m:r>
+                        <a:rPr lang="en-GB" sz="1050" b="1" i="1" dirty="0">
+                          <a:solidFill>
+                            <a:srgbClr val="14B8A6"/>
+                          </a:solidFill>
+                          <a:latin typeface="Cambria Math" panose="02040503050406030204" pitchFamily="18" charset="0"/>
+                        </a:rPr>
+                        <m:t>+ </m:t>
+                      </m:r>
+                      <m:r>
+                        <a:rPr lang="en-GB" sz="1050" b="1" i="1" dirty="0">
+                          <a:solidFill>
+                            <a:srgbClr val="14B8A6"/>
+                          </a:solidFill>
+                          <a:latin typeface="Cambria Math" panose="02040503050406030204" pitchFamily="18" charset="0"/>
+                        </a:rPr>
+                        <m:t>𝑴</m:t>
+                      </m:r>
+                      <m:d>
+                        <m:dPr>
+                          <m:ctrlPr>
+                            <a:rPr lang="en-GB" sz="1050" b="1" i="1" dirty="0">
+                              <a:solidFill>
+                                <a:srgbClr val="14B8A6"/>
+                              </a:solidFill>
+                              <a:latin typeface="Cambria Math" panose="02040503050406030204" pitchFamily="18" charset="0"/>
+                            </a:rPr>
+                          </m:ctrlPr>
+                        </m:dPr>
+                        <m:e>
+                          <m:r>
+                            <a:rPr lang="en-GB" sz="1050" b="1" i="1" dirty="0">
+                              <a:solidFill>
+                                <a:srgbClr val="14B8A6"/>
+                              </a:solidFill>
+                              <a:latin typeface="Cambria Math" panose="02040503050406030204" pitchFamily="18" charset="0"/>
+                            </a:rPr>
+                            <m:t>𝟏</m:t>
+                          </m:r>
+                          <m:r>
+                            <a:rPr lang="en-GB" sz="1050" b="1" i="1" dirty="0">
+                              <a:solidFill>
+                                <a:srgbClr val="14B8A6"/>
+                              </a:solidFill>
+                              <a:latin typeface="Cambria Math" panose="02040503050406030204" pitchFamily="18" charset="0"/>
+                            </a:rPr>
+                            <m:t>−</m:t>
+                          </m:r>
+                          <m:sSub>
+                            <m:sSubPr>
+                              <m:ctrlPr>
+                                <a:rPr lang="en-GB" sz="1050" b="1" i="1" dirty="0">
+                                  <a:solidFill>
+                                    <a:srgbClr val="14B8A6"/>
+                                  </a:solidFill>
+                                  <a:latin typeface="Cambria Math" panose="02040503050406030204" pitchFamily="18" charset="0"/>
+                                </a:rPr>
+                              </m:ctrlPr>
+                            </m:sSubPr>
+                            <m:e>
+                              <m:r>
+                                <a:rPr lang="en-GB" sz="1050" b="1" i="1" dirty="0">
+                                  <a:solidFill>
+                                    <a:srgbClr val="14B8A6"/>
+                                  </a:solidFill>
+                                  <a:latin typeface="Cambria Math" panose="02040503050406030204" pitchFamily="18" charset="0"/>
+                                </a:rPr>
+                                <m:t>𝑽</m:t>
+                              </m:r>
+                            </m:e>
+                            <m:sub>
+                              <m:r>
+                                <a:rPr lang="en-GB" sz="1050" b="1" i="1" dirty="0">
+                                  <a:solidFill>
+                                    <a:srgbClr val="14B8A6"/>
+                                  </a:solidFill>
+                                  <a:latin typeface="Cambria Math" panose="02040503050406030204" pitchFamily="18" charset="0"/>
+                                </a:rPr>
+                                <m:t>𝒊𝒋</m:t>
+                              </m:r>
+                            </m:sub>
+                          </m:sSub>
+                        </m:e>
+                      </m:d>
+                      <m:sSub>
+                        <m:sSubPr>
+                          <m:ctrlPr>
+                            <a:rPr lang="en-GB" sz="1050" b="1" i="1" dirty="0" smtClean="0">
+                              <a:solidFill>
+                                <a:srgbClr val="14B8A6"/>
+                              </a:solidFill>
+                              <a:latin typeface="Cambria Math" panose="02040503050406030204" pitchFamily="18" charset="0"/>
+                            </a:rPr>
+                          </m:ctrlPr>
+                        </m:sSubPr>
+                        <m:e>
+                          <m:r>
+                            <a:rPr lang="en-GB" sz="1050" b="1" i="1" dirty="0" smtClean="0">
+                              <a:solidFill>
+                                <a:srgbClr val="14B8A6"/>
+                              </a:solidFill>
+                              <a:latin typeface="Cambria Math" panose="02040503050406030204" pitchFamily="18" charset="0"/>
+                            </a:rPr>
+                            <m:t>𝒙</m:t>
+                          </m:r>
+                        </m:e>
+                        <m:sub>
+                          <m:r>
+                            <a:rPr lang="en-GB" sz="1050" b="1" i="1" dirty="0" smtClean="0">
+                              <a:solidFill>
+                                <a:srgbClr val="14B8A6"/>
+                              </a:solidFill>
+                              <a:latin typeface="Cambria Math" panose="02040503050406030204" pitchFamily="18" charset="0"/>
+                            </a:rPr>
+                            <m:t>𝒊</m:t>
+                          </m:r>
+                        </m:sub>
+                      </m:sSub>
+                      <m:r>
+                        <a:rPr lang="en-GB" sz="1050" b="1" i="1" dirty="0">
+                          <a:solidFill>
+                            <a:srgbClr val="14B8A6"/>
+                          </a:solidFill>
+                          <a:latin typeface="Cambria Math" panose="02040503050406030204" pitchFamily="18" charset="0"/>
+                        </a:rPr>
+                        <m:t>+ </m:t>
+                      </m:r>
+                      <m:r>
+                        <a:rPr lang="en-GB" sz="1050" b="1" i="1" dirty="0" err="1">
+                          <a:solidFill>
+                            <a:srgbClr val="14B8A6"/>
+                          </a:solidFill>
+                          <a:latin typeface="Cambria Math" panose="02040503050406030204" pitchFamily="18" charset="0"/>
+                        </a:rPr>
+                        <m:t>𝒅</m:t>
+                      </m:r>
+                      <m:sSub>
+                        <m:sSubPr>
+                          <m:ctrlPr>
+                            <a:rPr lang="en-GB" sz="1050" b="1" i="1" dirty="0" err="1">
+                              <a:solidFill>
+                                <a:srgbClr val="14B8A6"/>
+                              </a:solidFill>
+                              <a:latin typeface="Cambria Math" panose="02040503050406030204" pitchFamily="18" charset="0"/>
+                            </a:rPr>
+                          </m:ctrlPr>
+                        </m:sSubPr>
+                        <m:e>
+                          <m:r>
+                            <a:rPr lang="en-GB" sz="1050" b="1" i="1" dirty="0" err="1">
+                              <a:solidFill>
+                                <a:srgbClr val="14B8A6"/>
+                              </a:solidFill>
+                              <a:latin typeface="Cambria Math" panose="02040503050406030204" pitchFamily="18" charset="0"/>
+                            </a:rPr>
+                            <m:t>𝒙</m:t>
+                          </m:r>
+                        </m:e>
+                        <m:sub>
+                          <m:r>
+                            <a:rPr lang="en-GB" sz="1050" b="1" i="1" dirty="0" err="1">
+                              <a:solidFill>
+                                <a:srgbClr val="14B8A6"/>
+                              </a:solidFill>
+                              <a:latin typeface="Cambria Math" panose="02040503050406030204" pitchFamily="18" charset="0"/>
+                            </a:rPr>
+                            <m:t>𝒊</m:t>
+                          </m:r>
+                        </m:sub>
+                      </m:sSub>
+                      <m:r>
+                        <a:rPr lang="en-GB" sz="1050" b="1" i="1" dirty="0">
+                          <a:solidFill>
+                            <a:srgbClr val="14B8A6"/>
+                          </a:solidFill>
+                          <a:latin typeface="Cambria Math" panose="02040503050406030204" pitchFamily="18" charset="0"/>
+                        </a:rPr>
+                        <m:t>≤ </m:t>
+                      </m:r>
+                      <m:sSub>
+                        <m:sSubPr>
+                          <m:ctrlPr>
+                            <a:rPr lang="en-GB" sz="1050" b="1" i="1" dirty="0" err="1">
+                              <a:solidFill>
+                                <a:srgbClr val="14B8A6"/>
+                              </a:solidFill>
+                              <a:latin typeface="Cambria Math" panose="02040503050406030204" pitchFamily="18" charset="0"/>
+                            </a:rPr>
+                          </m:ctrlPr>
+                        </m:sSubPr>
+                        <m:e>
+                          <m:r>
+                            <a:rPr lang="en-GB" sz="1050" b="1" i="1" dirty="0" err="1">
+                              <a:solidFill>
+                                <a:srgbClr val="14B8A6"/>
+                              </a:solidFill>
+                              <a:latin typeface="Cambria Math" panose="02040503050406030204" pitchFamily="18" charset="0"/>
+                            </a:rPr>
+                            <m:t>𝑳</m:t>
+                          </m:r>
+                        </m:e>
+                        <m:sub>
+                          <m:sSub>
+                            <m:sSubPr>
+                              <m:ctrlPr>
+                                <a:rPr lang="en-GB" sz="1050" b="1" i="1" dirty="0" err="1">
+                                  <a:solidFill>
+                                    <a:srgbClr val="14B8A6"/>
+                                  </a:solidFill>
+                                  <a:latin typeface="Cambria Math" panose="02040503050406030204" pitchFamily="18" charset="0"/>
+                                </a:rPr>
+                              </m:ctrlPr>
+                            </m:sSubPr>
+                            <m:e>
+                              <m:r>
+                                <a:rPr lang="en-GB" sz="1050" b="1" i="1" dirty="0" err="1">
+                                  <a:solidFill>
+                                    <a:srgbClr val="14B8A6"/>
+                                  </a:solidFill>
+                                  <a:latin typeface="Cambria Math" panose="02040503050406030204" pitchFamily="18" charset="0"/>
+                                </a:rPr>
+                                <m:t>𝑿</m:t>
+                              </m:r>
+                            </m:e>
+                            <m:sub>
+                              <m:r>
+                                <a:rPr lang="en-GB" sz="1050" b="1" i="1" dirty="0" err="1">
+                                  <a:solidFill>
+                                    <a:srgbClr val="14B8A6"/>
+                                  </a:solidFill>
+                                  <a:latin typeface="Cambria Math" panose="02040503050406030204" pitchFamily="18" charset="0"/>
+                                </a:rPr>
+                                <m:t>𝒋</m:t>
+                              </m:r>
+                            </m:sub>
+                          </m:sSub>
+                        </m:sub>
+                      </m:sSub>
+                      <m:r>
+                        <a:rPr lang="en-GB" sz="1050" b="1" i="1" dirty="0">
+                          <a:solidFill>
+                            <a:srgbClr val="14B8A6"/>
+                          </a:solidFill>
+                          <a:latin typeface="Cambria Math" panose="02040503050406030204" pitchFamily="18" charset="0"/>
+                        </a:rPr>
+                        <m:t>+ </m:t>
+                      </m:r>
+                      <m:r>
+                        <a:rPr lang="en-GB" sz="1050" b="1" i="1" dirty="0">
+                          <a:solidFill>
+                            <a:srgbClr val="14B8A6"/>
+                          </a:solidFill>
+                          <a:latin typeface="Cambria Math" panose="02040503050406030204" pitchFamily="18" charset="0"/>
+                        </a:rPr>
+                        <m:t>𝑴</m:t>
+                      </m:r>
+                      <m:d>
+                        <m:dPr>
+                          <m:ctrlPr>
+                            <a:rPr lang="en-GB" sz="1050" b="1" i="1" dirty="0">
+                              <a:solidFill>
+                                <a:srgbClr val="14B8A6"/>
+                              </a:solidFill>
+                              <a:latin typeface="Cambria Math" panose="02040503050406030204" pitchFamily="18" charset="0"/>
+                            </a:rPr>
+                          </m:ctrlPr>
+                        </m:dPr>
+                        <m:e>
+                          <m:r>
+                            <a:rPr lang="en-GB" sz="1050" b="1" i="1" dirty="0">
+                              <a:solidFill>
+                                <a:srgbClr val="14B8A6"/>
+                              </a:solidFill>
+                              <a:latin typeface="Cambria Math" panose="02040503050406030204" pitchFamily="18" charset="0"/>
+                            </a:rPr>
+                            <m:t>𝟏</m:t>
+                          </m:r>
+                          <m:r>
+                            <a:rPr lang="en-GB" sz="1050" b="1" i="1" dirty="0">
+                              <a:solidFill>
+                                <a:srgbClr val="14B8A6"/>
+                              </a:solidFill>
+                              <a:latin typeface="Cambria Math" panose="02040503050406030204" pitchFamily="18" charset="0"/>
+                            </a:rPr>
+                            <m:t>−</m:t>
+                          </m:r>
+                          <m:sSub>
+                            <m:sSubPr>
+                              <m:ctrlPr>
+                                <a:rPr lang="en-GB" sz="1050" b="1" i="1" dirty="0">
+                                  <a:solidFill>
+                                    <a:srgbClr val="14B8A6"/>
+                                  </a:solidFill>
+                                  <a:latin typeface="Cambria Math" panose="02040503050406030204" pitchFamily="18" charset="0"/>
+                                </a:rPr>
+                              </m:ctrlPr>
+                            </m:sSubPr>
+                            <m:e>
+                              <m:r>
+                                <a:rPr lang="en-GB" sz="1050" b="1" i="1" dirty="0">
+                                  <a:solidFill>
+                                    <a:srgbClr val="14B8A6"/>
+                                  </a:solidFill>
+                                  <a:latin typeface="Cambria Math" panose="02040503050406030204" pitchFamily="18" charset="0"/>
+                                </a:rPr>
+                                <m:t>𝑽</m:t>
+                              </m:r>
+                            </m:e>
+                            <m:sub>
+                              <m:r>
+                                <a:rPr lang="en-GB" sz="1050" b="1" i="1" dirty="0">
+                                  <a:solidFill>
+                                    <a:srgbClr val="14B8A6"/>
+                                  </a:solidFill>
+                                  <a:latin typeface="Cambria Math" panose="02040503050406030204" pitchFamily="18" charset="0"/>
+                                </a:rPr>
+                                <m:t>𝒊𝒋</m:t>
+                              </m:r>
+                            </m:sub>
+                          </m:sSub>
+                        </m:e>
+                      </m:d>
                     </m:oMath>
                   </m:oMathPara>
                 </a14:m>
+                <a:endParaRPr/>
               </a:p>
             </p:txBody>
           </p:sp>
         </mc:Choice>
-        <mc:Fallback>
+        <mc:Fallback xmlns="">
           <p:sp>
             <p:nvSpPr>
               <p:cNvPr id="18" name="TextBox 17"/>
@@ -28345,8 +29122,8 @@
           </a:p>
         </p:txBody>
       </p:sp>
-      <mc:AlternateContent xmlns:mc="http://schemas.openxmlformats.org/markup-compatibility/2006">
-        <mc:Choice xmlns:a14="http://schemas.microsoft.com/office/drawing/2010/main" Requires="a14">
+      <mc:AlternateContent xmlns:mc="http://schemas.openxmlformats.org/markup-compatibility/2006" xmlns:a14="http://schemas.microsoft.com/office/drawing/2010/main">
+        <mc:Choice Requires="a14">
           <p:sp>
             <p:nvSpPr>
               <p:cNvPr id="25" name="TextBox 24"/>
@@ -28371,76 +29148,6 @@
               <a:p>
                 <a:pPr algn="l"/>
                 <a14:m>
-                  <m:oMathPara xmlns:m="http://schemas.openxmlformats.org/officeDocument/2006/math">
-                    <m:oMathParaPr>
-                      <m:jc m:val="centerGroup"/>
-                    </m:oMathParaPr>
-                    <m:oMath xmlns:m="http://schemas.openxmlformats.org/officeDocument/2006/math">
-                      <m:r>
-                        <a:rPr lang="en-GB" sz="1050" b="1" i="1" dirty="0" smtClean="0">
-                          <a:solidFill>
-                            <a:srgbClr val="A78BFA"/>
-                          </a:solidFill>
-                          <a:latin typeface="Cambria Math" panose="02040503050406030204" pitchFamily="18" charset="0"/>
-                        </a:rPr>
-                        <m:t>𝒍𝒆𝒇𝒕</m:t>
-                      </m:r>
-                      <m:r>
-                        <a:rPr lang="en-GB" sz="1050" b="1" i="1" dirty="0" smtClean="0">
-                          <a:solidFill>
-                            <a:srgbClr val="A78BFA"/>
-                          </a:solidFill>
-                          <a:latin typeface="Cambria Math" panose="02040503050406030204" pitchFamily="18" charset="0"/>
-                        </a:rPr>
-                        <m:t> + </m:t>
-                      </m:r>
-                      <m:r>
-                        <a:rPr lang="en-GB" sz="1050" b="1" i="1" dirty="0" smtClean="0">
-                          <a:solidFill>
-                            <a:srgbClr val="A78BFA"/>
-                          </a:solidFill>
-                          <a:latin typeface="Cambria Math" panose="02040503050406030204" pitchFamily="18" charset="0"/>
-                        </a:rPr>
-                        <m:t>𝒓𝒊𝒈𝒉𝒕</m:t>
-                      </m:r>
-                      <m:r>
-                        <a:rPr lang="en-GB" sz="1050" b="1" i="1" dirty="0" smtClean="0">
-                          <a:solidFill>
-                            <a:srgbClr val="A78BFA"/>
-                          </a:solidFill>
-                          <a:latin typeface="Cambria Math" panose="02040503050406030204" pitchFamily="18" charset="0"/>
-                        </a:rPr>
-                        <m:t> + </m:t>
-                      </m:r>
-                      <m:r>
-                        <a:rPr lang="en-GB" sz="1050" b="1" i="1" dirty="0" smtClean="0">
-                          <a:solidFill>
-                            <a:srgbClr val="A78BFA"/>
-                          </a:solidFill>
-                          <a:latin typeface="Cambria Math" panose="02040503050406030204" pitchFamily="18" charset="0"/>
-                        </a:rPr>
-                        <m:t>𝒇𝒓𝒐𝒏𝒕</m:t>
-                      </m:r>
-                      <m:r>
-                        <a:rPr lang="en-GB" sz="1050" b="1" i="1" dirty="0" smtClean="0">
-                          <a:solidFill>
-                            <a:srgbClr val="A78BFA"/>
-                          </a:solidFill>
-                          <a:latin typeface="Cambria Math" panose="02040503050406030204" pitchFamily="18" charset="0"/>
-                        </a:rPr>
-                        <m:t> + </m:t>
-                      </m:r>
-                      <m:r>
-                        <a:rPr lang="en-GB" sz="1050" b="1" i="1" dirty="0" smtClean="0">
-                          <a:solidFill>
-                            <a:srgbClr val="A78BFA"/>
-                          </a:solidFill>
-                          <a:latin typeface="Cambria Math" panose="02040503050406030204" pitchFamily="18" charset="0"/>
-                        </a:rPr>
-                        <m:t>𝒃𝒂𝒄𝒌</m:t>
-                      </m:r>
-                    </m:oMath>
-                  </m:oMathPara>
                   <m:oMathPara xmlns:m="http://schemas.openxmlformats.org/officeDocument/2006/math">
                     <m:oMathParaPr>
                       <m:jc m:val="centerGroup"/>
@@ -28586,14 +29293,78 @@
                         </a:rPr>
                         <m:t>𝟏</m:t>
                       </m:r>
+                      <m:r>
+                        <a:rPr lang="en-GB" sz="1050" b="1" i="1" dirty="0" smtClean="0">
+                          <a:solidFill>
+                            <a:srgbClr val="A78BFA"/>
+                          </a:solidFill>
+                          <a:latin typeface="Cambria Math" panose="02040503050406030204" pitchFamily="18" charset="0"/>
+                        </a:rPr>
+                        <m:t>𝒍𝒆𝒇𝒕</m:t>
+                      </m:r>
+                      <m:r>
+                        <a:rPr lang="en-GB" sz="1050" b="1" i="1" dirty="0" smtClean="0">
+                          <a:solidFill>
+                            <a:srgbClr val="A78BFA"/>
+                          </a:solidFill>
+                          <a:latin typeface="Cambria Math" panose="02040503050406030204" pitchFamily="18" charset="0"/>
+                        </a:rPr>
+                        <m:t> + </m:t>
+                      </m:r>
+                      <m:r>
+                        <a:rPr lang="en-GB" sz="1050" b="1" i="1" dirty="0" smtClean="0">
+                          <a:solidFill>
+                            <a:srgbClr val="A78BFA"/>
+                          </a:solidFill>
+                          <a:latin typeface="Cambria Math" panose="02040503050406030204" pitchFamily="18" charset="0"/>
+                        </a:rPr>
+                        <m:t>𝒓𝒊𝒈𝒉𝒕</m:t>
+                      </m:r>
+                      <m:r>
+                        <a:rPr lang="en-GB" sz="1050" b="1" i="1" dirty="0" smtClean="0">
+                          <a:solidFill>
+                            <a:srgbClr val="A78BFA"/>
+                          </a:solidFill>
+                          <a:latin typeface="Cambria Math" panose="02040503050406030204" pitchFamily="18" charset="0"/>
+                        </a:rPr>
+                        <m:t> + </m:t>
+                      </m:r>
+                      <m:r>
+                        <a:rPr lang="en-GB" sz="1050" b="1" i="1" dirty="0" smtClean="0">
+                          <a:solidFill>
+                            <a:srgbClr val="A78BFA"/>
+                          </a:solidFill>
+                          <a:latin typeface="Cambria Math" panose="02040503050406030204" pitchFamily="18" charset="0"/>
+                        </a:rPr>
+                        <m:t>𝒇𝒓𝒐𝒏𝒕</m:t>
+                      </m:r>
+                      <m:r>
+                        <a:rPr lang="en-GB" sz="1050" b="1" i="1" dirty="0" smtClean="0">
+                          <a:solidFill>
+                            <a:srgbClr val="A78BFA"/>
+                          </a:solidFill>
+                          <a:latin typeface="Cambria Math" panose="02040503050406030204" pitchFamily="18" charset="0"/>
+                        </a:rPr>
+                        <m:t> + </m:t>
+                      </m:r>
+                      <m:r>
+                        <a:rPr lang="en-GB" sz="1050" b="1" i="1" dirty="0" smtClean="0">
+                          <a:solidFill>
+                            <a:srgbClr val="A78BFA"/>
+                          </a:solidFill>
+                          <a:latin typeface="Cambria Math" panose="02040503050406030204" pitchFamily="18" charset="0"/>
+                        </a:rPr>
+                        <m:t>𝒃𝒂𝒄𝒌</m:t>
+                      </m:r>
                     </m:oMath>
                   </m:oMathPara>
                 </a14:m>
+                <a:endParaRPr/>
               </a:p>
             </p:txBody>
           </p:sp>
         </mc:Choice>
-        <mc:Fallback>
+        <mc:Fallback xmlns="">
           <p:sp>
             <p:nvSpPr>
               <p:cNvPr id="25" name="TextBox 24"/>
@@ -28838,8 +29609,8 @@
           </a:p>
         </p:txBody>
       </p:sp>
-      <mc:AlternateContent xmlns:mc="http://schemas.openxmlformats.org/markup-compatibility/2006">
-        <mc:Choice xmlns:a14="http://schemas.microsoft.com/office/drawing/2010/main" Requires="a14">
+      <mc:AlternateContent xmlns:mc="http://schemas.openxmlformats.org/markup-compatibility/2006" xmlns:a14="http://schemas.microsoft.com/office/drawing/2010/main">
+        <mc:Choice Requires="a14">
           <p:sp>
             <p:nvSpPr>
               <p:cNvPr id="31" name="TextBox 30"/>
@@ -29311,7 +30082,7 @@
             </p:txBody>
           </p:sp>
         </mc:Choice>
-        <mc:Fallback>
+        <mc:Fallback xmlns="">
           <p:sp>
             <p:nvSpPr>
               <p:cNvPr id="31" name="TextBox 30"/>
@@ -29350,8 +30121,8 @@
           </p:sp>
         </mc:Fallback>
       </mc:AlternateContent>
-      <mc:AlternateContent xmlns:mc="http://schemas.openxmlformats.org/markup-compatibility/2006">
-        <mc:Choice xmlns:a14="http://schemas.microsoft.com/office/drawing/2010/main" Requires="a14">
+      <mc:AlternateContent xmlns:mc="http://schemas.openxmlformats.org/markup-compatibility/2006" xmlns:a14="http://schemas.microsoft.com/office/drawing/2010/main">
+        <mc:Choice Requires="a14">
           <p:sp>
             <p:nvSpPr>
               <p:cNvPr id="32" name="TextBox 31"/>
@@ -29376,334 +30147,6 @@
               <a:p>
                 <a:pPr algn="l"/>
                 <a14:m>
-                  <m:oMathPara xmlns:m="http://schemas.openxmlformats.org/officeDocument/2006/math">
-                    <m:oMathParaPr>
-                      <m:jc m:val="centerGroup"/>
-                    </m:oMathParaPr>
-                    <m:oMath xmlns:m="http://schemas.openxmlformats.org/officeDocument/2006/math">
-                      <m:r>
-                        <a:rPr lang="en-GB" sz="1050" b="1" i="0" dirty="0" smtClean="0">
-                          <a:solidFill>
-                            <a:srgbClr val="F87171"/>
-                          </a:solidFill>
-                          <a:latin typeface="Cambria Math" panose="02040503050406030204" pitchFamily="18" charset="0"/>
-                        </a:rPr>
-                        <m:t>𝚺</m:t>
-                      </m:r>
-                      <m:r>
-                        <a:rPr lang="en-GB" sz="1050" b="1" i="1" dirty="0">
-                          <a:solidFill>
-                            <a:srgbClr val="F87171"/>
-                          </a:solidFill>
-                          <a:latin typeface="Cambria Math" panose="02040503050406030204" pitchFamily="18" charset="0"/>
-                        </a:rPr>
-                        <m:t> </m:t>
-                      </m:r>
-                      <m:sSub>
-                        <m:sSubPr>
-                          <m:ctrlPr>
-                            <a:rPr lang="en-GB" sz="1050" b="1" i="1" dirty="0" err="1">
-                              <a:solidFill>
-                                <a:srgbClr val="F87171"/>
-                              </a:solidFill>
-                              <a:latin typeface="Cambria Math" panose="02040503050406030204" pitchFamily="18" charset="0"/>
-                            </a:rPr>
-                          </m:ctrlPr>
-                        </m:sSubPr>
-                        <m:e>
-                          <m:r>
-                            <a:rPr lang="en-GB" sz="1050" b="1" i="1" dirty="0" err="1">
-                              <a:solidFill>
-                                <a:srgbClr val="F87171"/>
-                              </a:solidFill>
-                              <a:latin typeface="Cambria Math" panose="02040503050406030204" pitchFamily="18" charset="0"/>
-                            </a:rPr>
-                            <m:t>𝒘</m:t>
-                          </m:r>
-                        </m:e>
-                        <m:sub>
-                          <m:r>
-                            <a:rPr lang="en-GB" sz="1050" b="1" i="1" dirty="0" err="1">
-                              <a:solidFill>
-                                <a:srgbClr val="F87171"/>
-                              </a:solidFill>
-                              <a:latin typeface="Cambria Math" panose="02040503050406030204" pitchFamily="18" charset="0"/>
-                            </a:rPr>
-                            <m:t>𝒊</m:t>
-                          </m:r>
-                        </m:sub>
-                      </m:sSub>
-                      <m:r>
-                        <a:rPr lang="en-GB" sz="1050" b="1" i="1" dirty="0" err="1">
-                          <a:solidFill>
-                            <a:srgbClr val="F87171"/>
-                          </a:solidFill>
-                          <a:latin typeface="Cambria Math" panose="02040503050406030204" pitchFamily="18" charset="0"/>
-                        </a:rPr>
-                        <m:t>·</m:t>
-                      </m:r>
-                      <m:sSub>
-                        <m:sSubPr>
-                          <m:ctrlPr>
-                            <a:rPr lang="en-GB" sz="1050" b="1" i="1" dirty="0" err="1">
-                              <a:solidFill>
-                                <a:srgbClr val="F87171"/>
-                              </a:solidFill>
-                              <a:latin typeface="Cambria Math" panose="02040503050406030204" pitchFamily="18" charset="0"/>
-                            </a:rPr>
-                          </m:ctrlPr>
-                        </m:sSubPr>
-                        <m:e>
-                          <m:r>
-                            <a:rPr lang="en-GB" sz="1050" b="1" i="1" dirty="0" err="1">
-                              <a:solidFill>
-                                <a:srgbClr val="F87171"/>
-                              </a:solidFill>
-                              <a:latin typeface="Cambria Math" panose="02040503050406030204" pitchFamily="18" charset="0"/>
-                            </a:rPr>
-                            <m:t>𝒀</m:t>
-                          </m:r>
-                        </m:e>
-                        <m:sub>
-                          <m:r>
-                            <a:rPr lang="en-GB" sz="1050" b="1" i="1" dirty="0" err="1">
-                              <a:solidFill>
-                                <a:srgbClr val="F87171"/>
-                              </a:solidFill>
-                              <a:latin typeface="Cambria Math" panose="02040503050406030204" pitchFamily="18" charset="0"/>
-                            </a:rPr>
-                            <m:t>𝒂𝒃</m:t>
-                          </m:r>
-                          <m:sSub>
-                            <m:sSubPr>
-                              <m:ctrlPr>
-                                <a:rPr lang="en-GB" sz="1050" b="1" i="1" dirty="0" err="1">
-                                  <a:solidFill>
-                                    <a:srgbClr val="F87171"/>
-                                  </a:solidFill>
-                                  <a:latin typeface="Cambria Math" panose="02040503050406030204" pitchFamily="18" charset="0"/>
-                                </a:rPr>
-                              </m:ctrlPr>
-                            </m:sSubPr>
-                            <m:e>
-                              <m:r>
-                                <a:rPr lang="en-GB" sz="1050" b="1" i="1" dirty="0" err="1">
-                                  <a:solidFill>
-                                    <a:srgbClr val="F87171"/>
-                                  </a:solidFill>
-                                  <a:latin typeface="Cambria Math" panose="02040503050406030204" pitchFamily="18" charset="0"/>
-                                </a:rPr>
-                                <m:t>𝒔</m:t>
-                              </m:r>
-                            </m:e>
-                            <m:sub>
-                              <m:r>
-                                <a:rPr lang="en-GB" sz="1050" b="1" i="1" dirty="0" err="1">
-                                  <a:solidFill>
-                                    <a:srgbClr val="F87171"/>
-                                  </a:solidFill>
-                                  <a:latin typeface="Cambria Math" panose="02040503050406030204" pitchFamily="18" charset="0"/>
-                                </a:rPr>
-                                <m:t>𝒊</m:t>
-                              </m:r>
-                            </m:sub>
-                          </m:sSub>
-                        </m:sub>
-                      </m:sSub>
-                      <m:r>
-                        <a:rPr lang="en-GB" sz="1050" b="1" i="1" dirty="0">
-                          <a:solidFill>
-                            <a:srgbClr val="F87171"/>
-                          </a:solidFill>
-                          <a:latin typeface="Cambria Math" panose="02040503050406030204" pitchFamily="18" charset="0"/>
-                        </a:rPr>
-                        <m:t>≥ </m:t>
-                      </m:r>
-                      <m:r>
-                        <a:rPr lang="en-GB" sz="1050" b="1" i="1" dirty="0" err="1">
-                          <a:solidFill>
-                            <a:srgbClr val="F87171"/>
-                          </a:solidFill>
-                          <a:latin typeface="Cambria Math" panose="02040503050406030204" pitchFamily="18" charset="0"/>
-                        </a:rPr>
-                        <m:t>𝑪</m:t>
-                      </m:r>
-                      <m:sSub>
-                        <m:sSubPr>
-                          <m:ctrlPr>
-                            <a:rPr lang="en-GB" sz="1050" b="1" i="1" dirty="0" err="1">
-                              <a:solidFill>
-                                <a:srgbClr val="F87171"/>
-                              </a:solidFill>
-                              <a:latin typeface="Cambria Math" panose="02040503050406030204" pitchFamily="18" charset="0"/>
-                            </a:rPr>
-                          </m:ctrlPr>
-                        </m:sSubPr>
-                        <m:e>
-                          <m:r>
-                            <a:rPr lang="en-GB" sz="1050" b="1" i="1" dirty="0" err="1">
-                              <a:solidFill>
-                                <a:srgbClr val="F87171"/>
-                              </a:solidFill>
-                              <a:latin typeface="Cambria Math" panose="02040503050406030204" pitchFamily="18" charset="0"/>
-                            </a:rPr>
-                            <m:t>𝑮</m:t>
-                          </m:r>
-                        </m:e>
-                        <m:sub>
-                          <m:func>
-                            <m:funcPr>
-                              <m:ctrlPr>
-                                <a:rPr lang="en-GB" sz="1050" b="1" i="1" dirty="0">
-                                  <a:solidFill>
-                                    <a:srgbClr val="F87171"/>
-                                  </a:solidFill>
-                                  <a:latin typeface="Cambria Math" panose="02040503050406030204" pitchFamily="18" charset="0"/>
-                                </a:rPr>
-                              </m:ctrlPr>
-                            </m:funcPr>
-                            <m:fName>
-                              <m:r>
-                                <m:rPr>
-                                  <m:sty m:val="p"/>
-                                </m:rPr>
-                                <a:rPr lang="en-GB" sz="1050" b="0" i="0" dirty="0" err="1">
-                                  <a:solidFill>
-                                    <a:srgbClr val="F87171"/>
-                                  </a:solidFill>
-                                  <a:latin typeface="Cambria Math" panose="02040503050406030204" pitchFamily="18" charset="0"/>
-                                </a:rPr>
-                                <m:t>min</m:t>
-                              </m:r>
-                            </m:fName>
-                            <m:e/>
-                          </m:func>
-                        </m:sub>
-                      </m:sSub>
-                      <m:r>
-                        <a:rPr lang="en-GB" sz="1050" b="1" i="1" dirty="0">
-                          <a:solidFill>
-                            <a:srgbClr val="F87171"/>
-                          </a:solidFill>
-                          <a:latin typeface="Cambria Math" panose="02040503050406030204" pitchFamily="18" charset="0"/>
-                        </a:rPr>
-                        <m:t>· </m:t>
-                      </m:r>
-                      <m:r>
-                        <a:rPr lang="en-GB" sz="1050" b="1" i="0" dirty="0">
-                          <a:solidFill>
-                            <a:srgbClr val="F87171"/>
-                          </a:solidFill>
-                          <a:latin typeface="Cambria Math" panose="02040503050406030204" pitchFamily="18" charset="0"/>
-                        </a:rPr>
-                        <m:t>𝚺</m:t>
-                      </m:r>
-                      <m:r>
-                        <a:rPr lang="en-GB" sz="1050" b="1" i="1" dirty="0">
-                          <a:solidFill>
-                            <a:srgbClr val="F87171"/>
-                          </a:solidFill>
-                          <a:latin typeface="Cambria Math" panose="02040503050406030204" pitchFamily="18" charset="0"/>
-                        </a:rPr>
-                        <m:t> </m:t>
-                      </m:r>
-                      <m:r>
-                        <a:rPr lang="en-GB" sz="1050" b="1" i="0" dirty="0" err="1">
-                          <a:solidFill>
-                            <a:srgbClr val="F87171"/>
-                          </a:solidFill>
-                          <a:latin typeface="Cambria Math" panose="02040503050406030204" pitchFamily="18" charset="0"/>
-                        </a:rPr>
-                        <m:t>𝚺</m:t>
-                      </m:r>
-                      <m:r>
-                        <a:rPr lang="en-GB" sz="1050" b="1" i="1" dirty="0">
-                          <a:solidFill>
-                            <a:srgbClr val="F87171"/>
-                          </a:solidFill>
-                          <a:latin typeface="Cambria Math" panose="02040503050406030204" pitchFamily="18" charset="0"/>
-                        </a:rPr>
-                        <m:t> </m:t>
-                      </m:r>
-                      <m:sSub>
-                        <m:sSubPr>
-                          <m:ctrlPr>
-                            <a:rPr lang="en-GB" sz="1050" b="1" i="1" dirty="0" err="1">
-                              <a:solidFill>
-                                <a:srgbClr val="F87171"/>
-                              </a:solidFill>
-                              <a:latin typeface="Cambria Math" panose="02040503050406030204" pitchFamily="18" charset="0"/>
-                            </a:rPr>
-                          </m:ctrlPr>
-                        </m:sSubPr>
-                        <m:e>
-                          <m:r>
-                            <a:rPr lang="en-GB" sz="1050" b="1" i="1" dirty="0" err="1">
-                              <a:solidFill>
-                                <a:srgbClr val="F87171"/>
-                              </a:solidFill>
-                              <a:latin typeface="Cambria Math" panose="02040503050406030204" pitchFamily="18" charset="0"/>
-                            </a:rPr>
-                            <m:t>𝒘</m:t>
-                          </m:r>
-                        </m:e>
-                        <m:sub>
-                          <m:r>
-                            <a:rPr lang="en-GB" sz="1050" b="1" i="1" dirty="0" err="1">
-                              <a:solidFill>
-                                <a:srgbClr val="F87171"/>
-                              </a:solidFill>
-                              <a:latin typeface="Cambria Math" panose="02040503050406030204" pitchFamily="18" charset="0"/>
-                            </a:rPr>
-                            <m:t>𝒊</m:t>
-                          </m:r>
-                        </m:sub>
-                      </m:sSub>
-                      <m:r>
-                        <a:rPr lang="en-GB" sz="1050" b="1" i="1" dirty="0" err="1">
-                          <a:solidFill>
-                            <a:srgbClr val="F87171"/>
-                          </a:solidFill>
-                          <a:latin typeface="Cambria Math" panose="02040503050406030204" pitchFamily="18" charset="0"/>
-                        </a:rPr>
-                        <m:t>·</m:t>
-                      </m:r>
-                      <m:sSub>
-                        <m:sSubPr>
-                          <m:ctrlPr>
-                            <a:rPr lang="en-GB" sz="1050" b="1" i="1" dirty="0" err="1">
-                              <a:solidFill>
-                                <a:srgbClr val="F87171"/>
-                              </a:solidFill>
-                              <a:latin typeface="Cambria Math" panose="02040503050406030204" pitchFamily="18" charset="0"/>
-                            </a:rPr>
-                          </m:ctrlPr>
-                        </m:sSubPr>
-                        <m:e>
-                          <m:r>
-                            <a:rPr lang="en-GB" sz="1050" b="1" i="1" dirty="0" err="1">
-                              <a:solidFill>
-                                <a:srgbClr val="F87171"/>
-                              </a:solidFill>
-                              <a:latin typeface="Cambria Math" panose="02040503050406030204" pitchFamily="18" charset="0"/>
-                            </a:rPr>
-                            <m:t>𝑽</m:t>
-                          </m:r>
-                        </m:e>
-                        <m:sub>
-                          <m:r>
-                            <a:rPr lang="en-GB" sz="1050" b="1" i="1" dirty="0" err="1">
-                              <a:solidFill>
-                                <a:srgbClr val="F87171"/>
-                              </a:solidFill>
-                              <a:latin typeface="Cambria Math" panose="02040503050406030204" pitchFamily="18" charset="0"/>
-                            </a:rPr>
-                            <m:t>𝒊𝒋</m:t>
-                          </m:r>
-                        </m:sub>
-                      </m:sSub>
-                    </m:oMath>
-                  </m:oMathPara>
                   <m:oMathPara xmlns:m="http://schemas.openxmlformats.org/officeDocument/2006/math">
                     <m:oMathParaPr>
                       <m:jc m:val="centerGroup"/>
@@ -30030,14 +30473,336 @@
                           </m:r>
                         </m:sub>
                       </m:sSub>
+                      <m:r>
+                        <a:rPr lang="en-GB" sz="1050" b="1" i="0" dirty="0" smtClean="0">
+                          <a:solidFill>
+                            <a:srgbClr val="F87171"/>
+                          </a:solidFill>
+                          <a:latin typeface="Cambria Math" panose="02040503050406030204" pitchFamily="18" charset="0"/>
+                        </a:rPr>
+                        <m:t>𝚺</m:t>
+                      </m:r>
+                      <m:r>
+                        <a:rPr lang="en-GB" sz="1050" b="1" i="1" dirty="0">
+                          <a:solidFill>
+                            <a:srgbClr val="F87171"/>
+                          </a:solidFill>
+                          <a:latin typeface="Cambria Math" panose="02040503050406030204" pitchFamily="18" charset="0"/>
+                        </a:rPr>
+                        <m:t> </m:t>
+                      </m:r>
+                      <m:sSub>
+                        <m:sSubPr>
+                          <m:ctrlPr>
+                            <a:rPr lang="en-GB" sz="1050" b="1" i="1" dirty="0" err="1">
+                              <a:solidFill>
+                                <a:srgbClr val="F87171"/>
+                              </a:solidFill>
+                              <a:latin typeface="Cambria Math" panose="02040503050406030204" pitchFamily="18" charset="0"/>
+                            </a:rPr>
+                          </m:ctrlPr>
+                        </m:sSubPr>
+                        <m:e>
+                          <m:r>
+                            <a:rPr lang="en-GB" sz="1050" b="1" i="1" dirty="0" err="1">
+                              <a:solidFill>
+                                <a:srgbClr val="F87171"/>
+                              </a:solidFill>
+                              <a:latin typeface="Cambria Math" panose="02040503050406030204" pitchFamily="18" charset="0"/>
+                            </a:rPr>
+                            <m:t>𝒘</m:t>
+                          </m:r>
+                        </m:e>
+                        <m:sub>
+                          <m:r>
+                            <a:rPr lang="en-GB" sz="1050" b="1" i="1" dirty="0" err="1">
+                              <a:solidFill>
+                                <a:srgbClr val="F87171"/>
+                              </a:solidFill>
+                              <a:latin typeface="Cambria Math" panose="02040503050406030204" pitchFamily="18" charset="0"/>
+                            </a:rPr>
+                            <m:t>𝒊</m:t>
+                          </m:r>
+                        </m:sub>
+                      </m:sSub>
+                      <m:r>
+                        <a:rPr lang="en-GB" sz="1050" b="1" i="1" dirty="0" err="1">
+                          <a:solidFill>
+                            <a:srgbClr val="F87171"/>
+                          </a:solidFill>
+                          <a:latin typeface="Cambria Math" panose="02040503050406030204" pitchFamily="18" charset="0"/>
+                        </a:rPr>
+                        <m:t>·</m:t>
+                      </m:r>
+                      <m:sSub>
+                        <m:sSubPr>
+                          <m:ctrlPr>
+                            <a:rPr lang="en-GB" sz="1050" b="1" i="1" dirty="0" err="1">
+                              <a:solidFill>
+                                <a:srgbClr val="F87171"/>
+                              </a:solidFill>
+                              <a:latin typeface="Cambria Math" panose="02040503050406030204" pitchFamily="18" charset="0"/>
+                            </a:rPr>
+                          </m:ctrlPr>
+                        </m:sSubPr>
+                        <m:e>
+                          <m:r>
+                            <a:rPr lang="en-GB" sz="1050" b="1" i="1" dirty="0" err="1">
+                              <a:solidFill>
+                                <a:srgbClr val="F87171"/>
+                              </a:solidFill>
+                              <a:latin typeface="Cambria Math" panose="02040503050406030204" pitchFamily="18" charset="0"/>
+                            </a:rPr>
+                            <m:t>𝒀</m:t>
+                          </m:r>
+                        </m:e>
+                        <m:sub>
+                          <m:r>
+                            <a:rPr lang="en-GB" sz="1050" b="1" i="1" dirty="0" err="1">
+                              <a:solidFill>
+                                <a:srgbClr val="F87171"/>
+                              </a:solidFill>
+                              <a:latin typeface="Cambria Math" panose="02040503050406030204" pitchFamily="18" charset="0"/>
+                            </a:rPr>
+                            <m:t>𝒂𝒃</m:t>
+                          </m:r>
+                          <m:sSub>
+                            <m:sSubPr>
+                              <m:ctrlPr>
+                                <a:rPr lang="en-GB" sz="1050" b="1" i="1" dirty="0" err="1">
+                                  <a:solidFill>
+                                    <a:srgbClr val="F87171"/>
+                                  </a:solidFill>
+                                  <a:latin typeface="Cambria Math" panose="02040503050406030204" pitchFamily="18" charset="0"/>
+                                </a:rPr>
+                              </m:ctrlPr>
+                            </m:sSubPr>
+                            <m:e>
+                              <m:r>
+                                <a:rPr lang="en-GB" sz="1050" b="1" i="1" dirty="0" err="1">
+                                  <a:solidFill>
+                                    <a:srgbClr val="F87171"/>
+                                  </a:solidFill>
+                                  <a:latin typeface="Cambria Math" panose="02040503050406030204" pitchFamily="18" charset="0"/>
+                                </a:rPr>
+                                <m:t>𝒔</m:t>
+                              </m:r>
+                            </m:e>
+                            <m:sub>
+                              <m:r>
+                                <a:rPr lang="en-GB" sz="1050" b="1" i="1" dirty="0" err="1">
+                                  <a:solidFill>
+                                    <a:srgbClr val="F87171"/>
+                                  </a:solidFill>
+                                  <a:latin typeface="Cambria Math" panose="02040503050406030204" pitchFamily="18" charset="0"/>
+                                </a:rPr>
+                                <m:t>𝒊</m:t>
+                              </m:r>
+                            </m:sub>
+                          </m:sSub>
+                        </m:sub>
+                      </m:sSub>
+                      <m:r>
+                        <a:rPr lang="en-GB" sz="1050" b="1" i="1" dirty="0">
+                          <a:solidFill>
+                            <a:srgbClr val="F87171"/>
+                          </a:solidFill>
+                          <a:latin typeface="Cambria Math" panose="02040503050406030204" pitchFamily="18" charset="0"/>
+                        </a:rPr>
+                        <m:t>≥ </m:t>
+                      </m:r>
+                      <m:r>
+                        <a:rPr lang="en-GB" sz="1050" b="1" i="1" dirty="0" err="1">
+                          <a:solidFill>
+                            <a:srgbClr val="F87171"/>
+                          </a:solidFill>
+                          <a:latin typeface="Cambria Math" panose="02040503050406030204" pitchFamily="18" charset="0"/>
+                        </a:rPr>
+                        <m:t>𝑪</m:t>
+                      </m:r>
+                      <m:sSub>
+                        <m:sSubPr>
+                          <m:ctrlPr>
+                            <a:rPr lang="en-GB" sz="1050" b="1" i="1" dirty="0" err="1">
+                              <a:solidFill>
+                                <a:srgbClr val="F87171"/>
+                              </a:solidFill>
+                              <a:latin typeface="Cambria Math" panose="02040503050406030204" pitchFamily="18" charset="0"/>
+                            </a:rPr>
+                          </m:ctrlPr>
+                        </m:sSubPr>
+                        <m:e>
+                          <m:r>
+                            <a:rPr lang="en-GB" sz="1050" b="1" i="1" dirty="0" err="1">
+                              <a:solidFill>
+                                <a:srgbClr val="F87171"/>
+                              </a:solidFill>
+                              <a:latin typeface="Cambria Math" panose="02040503050406030204" pitchFamily="18" charset="0"/>
+                            </a:rPr>
+                            <m:t>𝑮</m:t>
+                          </m:r>
+                        </m:e>
+                        <m:sub>
+                          <m:func>
+                            <m:funcPr>
+                              <m:ctrlPr>
+                                <a:rPr lang="en-GB" sz="1050" b="1" i="1" dirty="0">
+                                  <a:solidFill>
+                                    <a:srgbClr val="F87171"/>
+                                  </a:solidFill>
+                                  <a:latin typeface="Cambria Math" panose="02040503050406030204" pitchFamily="18" charset="0"/>
+                                </a:rPr>
+                              </m:ctrlPr>
+                            </m:funcPr>
+                            <m:fName>
+                              <m:r>
+                                <m:rPr>
+                                  <m:sty m:val="p"/>
+                                </m:rPr>
+                                <a:rPr lang="en-GB" sz="1050" b="0" i="0" dirty="0" err="1">
+                                  <a:solidFill>
+                                    <a:srgbClr val="F87171"/>
+                                  </a:solidFill>
+                                  <a:latin typeface="Cambria Math" panose="02040503050406030204" pitchFamily="18" charset="0"/>
+                                </a:rPr>
+                                <m:t>min</m:t>
+                              </m:r>
+                            </m:fName>
+                            <m:e/>
+                          </m:func>
+                        </m:sub>
+                      </m:sSub>
+                      <m:r>
+                        <a:rPr lang="en-GB" sz="1050" b="1" i="1" dirty="0">
+                          <a:solidFill>
+                            <a:srgbClr val="F87171"/>
+                          </a:solidFill>
+                          <a:latin typeface="Cambria Math" panose="02040503050406030204" pitchFamily="18" charset="0"/>
+                        </a:rPr>
+                        <m:t>· </m:t>
+                      </m:r>
+                      <m:r>
+                        <a:rPr lang="en-GB" sz="1050" b="1" i="0" dirty="0">
+                          <a:solidFill>
+                            <a:srgbClr val="F87171"/>
+                          </a:solidFill>
+                          <a:latin typeface="Cambria Math" panose="02040503050406030204" pitchFamily="18" charset="0"/>
+                        </a:rPr>
+                        <m:t>𝚺</m:t>
+                      </m:r>
+                      <m:r>
+                        <a:rPr lang="en-GB" sz="1050" b="1" i="1" dirty="0">
+                          <a:solidFill>
+                            <a:srgbClr val="F87171"/>
+                          </a:solidFill>
+                          <a:latin typeface="Cambria Math" panose="02040503050406030204" pitchFamily="18" charset="0"/>
+                        </a:rPr>
+                        <m:t> </m:t>
+                      </m:r>
+                      <m:r>
+                        <a:rPr lang="en-GB" sz="1050" b="1" i="0" dirty="0" err="1">
+                          <a:solidFill>
+                            <a:srgbClr val="F87171"/>
+                          </a:solidFill>
+                          <a:latin typeface="Cambria Math" panose="02040503050406030204" pitchFamily="18" charset="0"/>
+                        </a:rPr>
+                        <m:t>𝚺</m:t>
+                      </m:r>
+                      <m:r>
+                        <a:rPr lang="en-GB" sz="1050" b="1" i="1" dirty="0">
+                          <a:solidFill>
+                            <a:srgbClr val="F87171"/>
+                          </a:solidFill>
+                          <a:latin typeface="Cambria Math" panose="02040503050406030204" pitchFamily="18" charset="0"/>
+                        </a:rPr>
+                        <m:t> </m:t>
+                      </m:r>
+                      <m:sSub>
+                        <m:sSubPr>
+                          <m:ctrlPr>
+                            <a:rPr lang="en-GB" sz="1050" b="1" i="1" dirty="0" err="1">
+                              <a:solidFill>
+                                <a:srgbClr val="F87171"/>
+                              </a:solidFill>
+                              <a:latin typeface="Cambria Math" panose="02040503050406030204" pitchFamily="18" charset="0"/>
+                            </a:rPr>
+                          </m:ctrlPr>
+                        </m:sSubPr>
+                        <m:e>
+                          <m:r>
+                            <a:rPr lang="en-GB" sz="1050" b="1" i="1" dirty="0" err="1">
+                              <a:solidFill>
+                                <a:srgbClr val="F87171"/>
+                              </a:solidFill>
+                              <a:latin typeface="Cambria Math" panose="02040503050406030204" pitchFamily="18" charset="0"/>
+                            </a:rPr>
+                            <m:t>𝒘</m:t>
+                          </m:r>
+                        </m:e>
+                        <m:sub>
+                          <m:r>
+                            <a:rPr lang="en-GB" sz="1050" b="1" i="1" dirty="0" err="1">
+                              <a:solidFill>
+                                <a:srgbClr val="F87171"/>
+                              </a:solidFill>
+                              <a:latin typeface="Cambria Math" panose="02040503050406030204" pitchFamily="18" charset="0"/>
+                            </a:rPr>
+                            <m:t>𝒊</m:t>
+                          </m:r>
+                        </m:sub>
+                      </m:sSub>
+                      <m:r>
+                        <a:rPr lang="en-GB" sz="1050" b="1" i="1" dirty="0" err="1">
+                          <a:solidFill>
+                            <a:srgbClr val="F87171"/>
+                          </a:solidFill>
+                          <a:latin typeface="Cambria Math" panose="02040503050406030204" pitchFamily="18" charset="0"/>
+                        </a:rPr>
+                        <m:t>·</m:t>
+                      </m:r>
+                      <m:sSub>
+                        <m:sSubPr>
+                          <m:ctrlPr>
+                            <a:rPr lang="en-GB" sz="1050" b="1" i="1" dirty="0" err="1">
+                              <a:solidFill>
+                                <a:srgbClr val="F87171"/>
+                              </a:solidFill>
+                              <a:latin typeface="Cambria Math" panose="02040503050406030204" pitchFamily="18" charset="0"/>
+                            </a:rPr>
+                          </m:ctrlPr>
+                        </m:sSubPr>
+                        <m:e>
+                          <m:r>
+                            <a:rPr lang="en-GB" sz="1050" b="1" i="1" dirty="0" err="1">
+                              <a:solidFill>
+                                <a:srgbClr val="F87171"/>
+                              </a:solidFill>
+                              <a:latin typeface="Cambria Math" panose="02040503050406030204" pitchFamily="18" charset="0"/>
+                            </a:rPr>
+                            <m:t>𝑽</m:t>
+                          </m:r>
+                        </m:e>
+                        <m:sub>
+                          <m:r>
+                            <a:rPr lang="en-GB" sz="1050" b="1" i="1" dirty="0" err="1">
+                              <a:solidFill>
+                                <a:srgbClr val="F87171"/>
+                              </a:solidFill>
+                              <a:latin typeface="Cambria Math" panose="02040503050406030204" pitchFamily="18" charset="0"/>
+                            </a:rPr>
+                            <m:t>𝒊𝒋</m:t>
+                          </m:r>
+                        </m:sub>
+                      </m:sSub>
                     </m:oMath>
                   </m:oMathPara>
                 </a14:m>
+                <a:endParaRPr/>
               </a:p>
             </p:txBody>
           </p:sp>
         </mc:Choice>
-        <mc:Fallback>
+        <mc:Fallback xmlns="">
           <p:sp>
             <p:nvSpPr>
               <p:cNvPr id="32" name="TextBox 31"/>
@@ -30081,6 +30846,18 @@
   <p:clrMapOvr>
     <a:masterClrMapping/>
   </p:clrMapOvr>
+  <mc:AlternateContent xmlns:mc="http://schemas.openxmlformats.org/markup-compatibility/2006">
+    <mc:Choice xmlns:p159="http://schemas.microsoft.com/office/powerpoint/2015/09/main" Requires="p159">
+      <p:transition xmlns:p14="http://schemas.microsoft.com/office/powerpoint/2010/main" spd="slow" p14:dur="2000">
+        <p159:morph option="byObject"/>
+      </p:transition>
+    </mc:Choice>
+    <mc:Fallback>
+      <p:transition spd="slow">
+        <p:fade/>
+      </p:transition>
+    </mc:Fallback>
+  </mc:AlternateContent>
 </p:sld>
 </file>
 
@@ -30746,8 +31523,8 @@
           </a:p>
         </p:txBody>
       </p:sp>
-      <mc:AlternateContent xmlns:mc="http://schemas.openxmlformats.org/markup-compatibility/2006">
-        <mc:Choice xmlns:a14="http://schemas.microsoft.com/office/drawing/2010/main" Requires="a14">
+      <mc:AlternateContent xmlns:mc="http://schemas.openxmlformats.org/markup-compatibility/2006" xmlns:a14="http://schemas.microsoft.com/office/drawing/2010/main">
+        <mc:Choice Requires="a14">
           <p:sp>
             <p:nvSpPr>
               <p:cNvPr id="17" name="TextBox 16"/>
@@ -30855,7 +31632,7 @@
             </p:txBody>
           </p:sp>
         </mc:Choice>
-        <mc:Fallback>
+        <mc:Fallback xmlns="">
           <p:sp>
             <p:nvSpPr>
               <p:cNvPr id="17" name="TextBox 16"/>
@@ -31058,8 +31835,8 @@
           </a:p>
         </p:txBody>
       </p:sp>
-      <mc:AlternateContent xmlns:mc="http://schemas.openxmlformats.org/markup-compatibility/2006">
-        <mc:Choice xmlns:a14="http://schemas.microsoft.com/office/drawing/2010/main" Requires="a14">
+      <mc:AlternateContent xmlns:mc="http://schemas.openxmlformats.org/markup-compatibility/2006" xmlns:a14="http://schemas.microsoft.com/office/drawing/2010/main">
+        <mc:Choice Requires="a14">
           <p:sp>
             <p:nvSpPr>
               <p:cNvPr id="22" name="TextBox 21"/>
@@ -31176,7 +31953,7 @@
             </p:txBody>
           </p:sp>
         </mc:Choice>
-        <mc:Fallback>
+        <mc:Fallback xmlns="">
           <p:sp>
             <p:nvSpPr>
               <p:cNvPr id="22" name="TextBox 21"/>
@@ -31698,6 +32475,18 @@
   <p:clrMapOvr>
     <a:masterClrMapping/>
   </p:clrMapOvr>
+  <mc:AlternateContent xmlns:mc="http://schemas.openxmlformats.org/markup-compatibility/2006">
+    <mc:Choice xmlns:p159="http://schemas.microsoft.com/office/powerpoint/2015/09/main" Requires="p159">
+      <p:transition xmlns:p14="http://schemas.microsoft.com/office/powerpoint/2010/main" spd="slow" p14:dur="2000">
+        <p159:morph option="byObject"/>
+      </p:transition>
+    </mc:Choice>
+    <mc:Fallback>
+      <p:transition spd="slow">
+        <p:fade/>
+      </p:transition>
+    </mc:Fallback>
+  </mc:AlternateContent>
 </p:sld>
 </file>
 
@@ -33203,7 +33992,7 @@
         </p:nvSpPr>
         <p:spPr>
           <a:xfrm>
-            <a:off x="4160520" y="3429000"/>
+            <a:off x="4160520" y="3375212"/>
             <a:ext cx="365760" cy="523220"/>
           </a:xfrm>
           <a:prstGeom prst="rect">
@@ -33219,7 +34008,7 @@
           <a:p>
             <a:pPr algn="ctr"/>
             <a:r>
-              <a:rPr sz="2800" b="1" i="0">
+              <a:rPr sz="2800" b="1" i="0" dirty="0">
                 <a:solidFill>
                   <a:srgbClr val="38BDF8"/>
                 </a:solidFill>
@@ -33282,7 +34071,7 @@
         </p:nvSpPr>
         <p:spPr>
           <a:xfrm>
-            <a:off x="8138159" y="3429000"/>
+            <a:off x="8138159" y="3375212"/>
             <a:ext cx="365760" cy="523220"/>
           </a:xfrm>
           <a:prstGeom prst="rect">
@@ -33666,6 +34455,18 @@
   <p:clrMapOvr>
     <a:masterClrMapping/>
   </p:clrMapOvr>
+  <mc:AlternateContent xmlns:mc="http://schemas.openxmlformats.org/markup-compatibility/2006">
+    <mc:Choice xmlns:p159="http://schemas.microsoft.com/office/powerpoint/2015/09/main" Requires="p159">
+      <p:transition xmlns:p14="http://schemas.microsoft.com/office/powerpoint/2010/main" spd="slow" p14:dur="2000">
+        <p159:morph option="byObject"/>
+      </p:transition>
+    </mc:Choice>
+    <mc:Fallback>
+      <p:transition spd="slow">
+        <p:fade/>
+      </p:transition>
+    </mc:Fallback>
+  </mc:AlternateContent>
 </p:sld>
 </file>
 
@@ -35546,6 +36347,18 @@
   <p:clrMapOvr>
     <a:masterClrMapping/>
   </p:clrMapOvr>
+  <mc:AlternateContent xmlns:mc="http://schemas.openxmlformats.org/markup-compatibility/2006">
+    <mc:Choice xmlns:p159="http://schemas.microsoft.com/office/powerpoint/2015/09/main" Requires="p159">
+      <p:transition xmlns:p14="http://schemas.microsoft.com/office/powerpoint/2010/main" spd="slow" p14:dur="2000">
+        <p159:morph option="byObject"/>
+      </p:transition>
+    </mc:Choice>
+    <mc:Fallback>
+      <p:transition spd="slow">
+        <p:fade/>
+      </p:transition>
+    </mc:Fallback>
+  </mc:AlternateContent>
 </p:sld>
 </file>
 
@@ -35867,4 +36680,299 @@
   </a:objectDefaults>
   <a:extraClrSchemeLst/>
 </a:theme>
+</file>
+
+<file path=ppt/theme/theme2.xml><?xml version="1.0" encoding="utf-8"?>
+<a:theme xmlns:a="http://schemas.openxmlformats.org/drawingml/2006/main" name="Office Theme">
+  <a:themeElements>
+    <a:clrScheme name="Office">
+      <a:dk1>
+        <a:sysClr val="windowText" lastClr="000000"/>
+      </a:dk1>
+      <a:lt1>
+        <a:sysClr val="window" lastClr="FFFFFF"/>
+      </a:lt1>
+      <a:dk2>
+        <a:srgbClr val="44546A"/>
+      </a:dk2>
+      <a:lt2>
+        <a:srgbClr val="E7E6E6"/>
+      </a:lt2>
+      <a:accent1>
+        <a:srgbClr val="4472C4"/>
+      </a:accent1>
+      <a:accent2>
+        <a:srgbClr val="ED7D31"/>
+      </a:accent2>
+      <a:accent3>
+        <a:srgbClr val="A5A5A5"/>
+      </a:accent3>
+      <a:accent4>
+        <a:srgbClr val="FFC000"/>
+      </a:accent4>
+      <a:accent5>
+        <a:srgbClr val="5B9BD5"/>
+      </a:accent5>
+      <a:accent6>
+        <a:srgbClr val="70AD47"/>
+      </a:accent6>
+      <a:hlink>
+        <a:srgbClr val="0563C1"/>
+      </a:hlink>
+      <a:folHlink>
+        <a:srgbClr val="954F72"/>
+      </a:folHlink>
+    </a:clrScheme>
+    <a:fontScheme name="Office">
+      <a:majorFont>
+        <a:latin typeface="Calibri Light" panose="020F0302020204030204"/>
+        <a:ea typeface=""/>
+        <a:cs typeface=""/>
+        <a:font script="Jpan" typeface="游ゴシック Light"/>
+        <a:font script="Hang" typeface="맑은 고딕"/>
+        <a:font script="Hans" typeface="等线 Light"/>
+        <a:font script="Hant" typeface="新細明體"/>
+        <a:font script="Arab" typeface="Times New Roman"/>
+        <a:font script="Hebr" typeface="Times New Roman"/>
+        <a:font script="Thai" typeface="Angsana New"/>
+        <a:font script="Ethi" typeface="Nyala"/>
+        <a:font script="Beng" typeface="Vrinda"/>
+        <a:font script="Gujr" typeface="Shruti"/>
+        <a:font script="Khmr" typeface="MoolBoran"/>
+        <a:font script="Knda" typeface="Tunga"/>
+        <a:font script="Guru" typeface="Raavi"/>
+        <a:font script="Cans" typeface="Euphemia"/>
+        <a:font script="Cher" typeface="Plantagenet Cherokee"/>
+        <a:font script="Yiii" typeface="Microsoft Yi Baiti"/>
+        <a:font script="Tibt" typeface="Microsoft Himalaya"/>
+        <a:font script="Thaa" typeface="MV Boli"/>
+        <a:font script="Deva" typeface="Mangal"/>
+        <a:font script="Telu" typeface="Gautami"/>
+        <a:font script="Taml" typeface="Latha"/>
+        <a:font script="Syrc" typeface="Estrangelo Edessa"/>
+        <a:font script="Orya" typeface="Kalinga"/>
+        <a:font script="Mlym" typeface="Kartika"/>
+        <a:font script="Laoo" typeface="DokChampa"/>
+        <a:font script="Sinh" typeface="Iskoola Pota"/>
+        <a:font script="Mong" typeface="Mongolian Baiti"/>
+        <a:font script="Viet" typeface="Times New Roman"/>
+        <a:font script="Uigh" typeface="Microsoft Uighur"/>
+        <a:font script="Geor" typeface="Sylfaen"/>
+        <a:font script="Armn" typeface="Arial"/>
+        <a:font script="Bugi" typeface="Leelawadee UI"/>
+        <a:font script="Bopo" typeface="Microsoft JhengHei"/>
+        <a:font script="Java" typeface="Javanese Text"/>
+        <a:font script="Lisu" typeface="Segoe UI"/>
+        <a:font script="Mymr" typeface="Myanmar Text"/>
+        <a:font script="Nkoo" typeface="Ebrima"/>
+        <a:font script="Olck" typeface="Nirmala UI"/>
+        <a:font script="Osma" typeface="Ebrima"/>
+        <a:font script="Phag" typeface="Phagspa"/>
+        <a:font script="Syrn" typeface="Estrangelo Edessa"/>
+        <a:font script="Syrj" typeface="Estrangelo Edessa"/>
+        <a:font script="Syre" typeface="Estrangelo Edessa"/>
+        <a:font script="Sora" typeface="Nirmala UI"/>
+        <a:font script="Tale" typeface="Microsoft Tai Le"/>
+        <a:font script="Talu" typeface="Microsoft New Tai Lue"/>
+        <a:font script="Tfng" typeface="Ebrima"/>
+      </a:majorFont>
+      <a:minorFont>
+        <a:latin typeface="Calibri" panose="020F0502020204030204"/>
+        <a:ea typeface=""/>
+        <a:cs typeface=""/>
+        <a:font script="Jpan" typeface="游ゴシック"/>
+        <a:font script="Hang" typeface="맑은 고딕"/>
+        <a:font script="Hans" typeface="等线"/>
+        <a:font script="Hant" typeface="新細明體"/>
+        <a:font script="Arab" typeface="Arial"/>
+        <a:font script="Hebr" typeface="Arial"/>
+        <a:font script="Thai" typeface="Cordia New"/>
+        <a:font script="Ethi" typeface="Nyala"/>
+        <a:font script="Beng" typeface="Vrinda"/>
+        <a:font script="Gujr" typeface="Shruti"/>
+        <a:font script="Khmr" typeface="DaunPenh"/>
+        <a:font script="Knda" typeface="Tunga"/>
+        <a:font script="Guru" typeface="Raavi"/>
+        <a:font script="Cans" typeface="Euphemia"/>
+        <a:font script="Cher" typeface="Plantagenet Cherokee"/>
+        <a:font script="Yiii" typeface="Microsoft Yi Baiti"/>
+        <a:font script="Tibt" typeface="Microsoft Himalaya"/>
+        <a:font script="Thaa" typeface="MV Boli"/>
+        <a:font script="Deva" typeface="Mangal"/>
+        <a:font script="Telu" typeface="Gautami"/>
+        <a:font script="Taml" typeface="Latha"/>
+        <a:font script="Syrc" typeface="Estrangelo Edessa"/>
+        <a:font script="Orya" typeface="Kalinga"/>
+        <a:font script="Mlym" typeface="Kartika"/>
+        <a:font script="Laoo" typeface="DokChampa"/>
+        <a:font script="Sinh" typeface="Iskoola Pota"/>
+        <a:font script="Mong" typeface="Mongolian Baiti"/>
+        <a:font script="Viet" typeface="Arial"/>
+        <a:font script="Uigh" typeface="Microsoft Uighur"/>
+        <a:font script="Geor" typeface="Sylfaen"/>
+        <a:font script="Armn" typeface="Arial"/>
+        <a:font script="Bugi" typeface="Leelawadee UI"/>
+        <a:font script="Bopo" typeface="Microsoft JhengHei"/>
+        <a:font script="Java" typeface="Javanese Text"/>
+        <a:font script="Lisu" typeface="Segoe UI"/>
+        <a:font script="Mymr" typeface="Myanmar Text"/>
+        <a:font script="Nkoo" typeface="Ebrima"/>
+        <a:font script="Olck" typeface="Nirmala UI"/>
+        <a:font script="Osma" typeface="Ebrima"/>
+        <a:font script="Phag" typeface="Phagspa"/>
+        <a:font script="Syrn" typeface="Estrangelo Edessa"/>
+        <a:font script="Syrj" typeface="Estrangelo Edessa"/>
+        <a:font script="Syre" typeface="Estrangelo Edessa"/>
+        <a:font script="Sora" typeface="Nirmala UI"/>
+        <a:font script="Tale" typeface="Microsoft Tai Le"/>
+        <a:font script="Talu" typeface="Microsoft New Tai Lue"/>
+        <a:font script="Tfng" typeface="Ebrima"/>
+      </a:minorFont>
+    </a:fontScheme>
+    <a:fmtScheme name="Office">
+      <a:fillStyleLst>
+        <a:solidFill>
+          <a:schemeClr val="phClr"/>
+        </a:solidFill>
+        <a:gradFill rotWithShape="1">
+          <a:gsLst>
+            <a:gs pos="0">
+              <a:schemeClr val="phClr">
+                <a:lumMod val="110000"/>
+                <a:satMod val="105000"/>
+                <a:tint val="67000"/>
+              </a:schemeClr>
+            </a:gs>
+            <a:gs pos="50000">
+              <a:schemeClr val="phClr">
+                <a:lumMod val="105000"/>
+                <a:satMod val="103000"/>
+                <a:tint val="73000"/>
+              </a:schemeClr>
+            </a:gs>
+            <a:gs pos="100000">
+              <a:schemeClr val="phClr">
+                <a:lumMod val="105000"/>
+                <a:satMod val="109000"/>
+                <a:tint val="81000"/>
+              </a:schemeClr>
+            </a:gs>
+          </a:gsLst>
+          <a:lin ang="5400000" scaled="0"/>
+        </a:gradFill>
+        <a:gradFill rotWithShape="1">
+          <a:gsLst>
+            <a:gs pos="0">
+              <a:schemeClr val="phClr">
+                <a:satMod val="103000"/>
+                <a:lumMod val="102000"/>
+                <a:tint val="94000"/>
+              </a:schemeClr>
+            </a:gs>
+            <a:gs pos="50000">
+              <a:schemeClr val="phClr">
+                <a:satMod val="110000"/>
+                <a:lumMod val="100000"/>
+                <a:shade val="100000"/>
+              </a:schemeClr>
+            </a:gs>
+            <a:gs pos="100000">
+              <a:schemeClr val="phClr">
+                <a:lumMod val="99000"/>
+                <a:satMod val="120000"/>
+                <a:shade val="78000"/>
+              </a:schemeClr>
+            </a:gs>
+          </a:gsLst>
+          <a:lin ang="5400000" scaled="0"/>
+        </a:gradFill>
+      </a:fillStyleLst>
+      <a:lnStyleLst>
+        <a:ln w="6350" cap="flat" cmpd="sng" algn="ctr">
+          <a:solidFill>
+            <a:schemeClr val="phClr"/>
+          </a:solidFill>
+          <a:prstDash val="solid"/>
+          <a:miter lim="800000"/>
+        </a:ln>
+        <a:ln w="12700" cap="flat" cmpd="sng" algn="ctr">
+          <a:solidFill>
+            <a:schemeClr val="phClr"/>
+          </a:solidFill>
+          <a:prstDash val="solid"/>
+          <a:miter lim="800000"/>
+        </a:ln>
+        <a:ln w="19050" cap="flat" cmpd="sng" algn="ctr">
+          <a:solidFill>
+            <a:schemeClr val="phClr"/>
+          </a:solidFill>
+          <a:prstDash val="solid"/>
+          <a:miter lim="800000"/>
+        </a:ln>
+      </a:lnStyleLst>
+      <a:effectStyleLst>
+        <a:effectStyle>
+          <a:effectLst/>
+        </a:effectStyle>
+        <a:effectStyle>
+          <a:effectLst/>
+        </a:effectStyle>
+        <a:effectStyle>
+          <a:effectLst>
+            <a:outerShdw blurRad="57150" dist="19050" dir="5400000" algn="ctr" rotWithShape="0">
+              <a:srgbClr val="000000">
+                <a:alpha val="63000"/>
+              </a:srgbClr>
+            </a:outerShdw>
+          </a:effectLst>
+        </a:effectStyle>
+      </a:effectStyleLst>
+      <a:bgFillStyleLst>
+        <a:solidFill>
+          <a:schemeClr val="phClr"/>
+        </a:solidFill>
+        <a:solidFill>
+          <a:schemeClr val="phClr">
+            <a:tint val="95000"/>
+            <a:satMod val="170000"/>
+          </a:schemeClr>
+        </a:solidFill>
+        <a:gradFill rotWithShape="1">
+          <a:gsLst>
+            <a:gs pos="0">
+              <a:schemeClr val="phClr">
+                <a:tint val="93000"/>
+                <a:satMod val="150000"/>
+                <a:shade val="98000"/>
+                <a:lumMod val="102000"/>
+              </a:schemeClr>
+            </a:gs>
+            <a:gs pos="50000">
+              <a:schemeClr val="phClr">
+                <a:tint val="98000"/>
+                <a:satMod val="130000"/>
+                <a:shade val="90000"/>
+                <a:lumMod val="103000"/>
+              </a:schemeClr>
+            </a:gs>
+            <a:gs pos="100000">
+              <a:schemeClr val="phClr">
+                <a:shade val="63000"/>
+                <a:satMod val="120000"/>
+              </a:schemeClr>
+            </a:gs>
+          </a:gsLst>
+          <a:lin ang="5400000" scaled="0"/>
+        </a:gradFill>
+      </a:bgFillStyleLst>
+    </a:fmtScheme>
+  </a:themeElements>
+  <a:objectDefaults/>
+  <a:extraClrSchemeLst/>
+  <a:extLst>
+    <a:ext uri="{05A4C25C-085E-4340-85A3-A5531E510DB2}">
+      <thm15:themeFamily xmlns:thm15="http://schemas.microsoft.com/office/thememl/2012/main" name="Office Theme" id="{62F939B6-93AF-4DB8-9C6B-D6C7DFDC589F}" vid="{4A3C46E8-61CC-4603-A589-7422A47A8E4A}"/>
+    </a:ext>
+  </a:extLst>
+</a:theme>
 </file>
</xml_diff>